<commit_message>
Translate all lab content to Thai and Hindi; update HTML and PPTX decks for 6 languages
- All 6 labs now include th/hi for every localized string
- HTML deck: Thai/Hindi added to the in-deck language switcher and translation packs; content updated to 6 languages
- PPTX deck: language claims updated to 6, language lists include Thai and Hindi
</commit_message>
<xml_diff>
--- a/promo/JumpStart-v2-Workshop-Highlights.pptx
+++ b/promo/JumpStart-v2-Workshop-Highlights.pptx
@@ -4,9 +4,6 @@
   <p:sldMasterIdLst>
     <p:sldMasterId id="2147483648" r:id="rId1"/>
   </p:sldMasterIdLst>
-  <p:notesMasterIdLst>
-    <p:notesMasterId r:id="rId11"/>
-  </p:notesMasterIdLst>
   <p:sldIdLst>
     <p:sldId id="256" r:id="rId2"/>
     <p:sldId id="257" r:id="rId3"/>
@@ -18,8 +15,11 @@
     <p:sldId id="263" r:id="rId9"/>
     <p:sldId id="264" r:id="rId10"/>
   </p:sldIdLst>
-  <p:sldSz cx="12192000" cy="6858000"/>
-  <p:notesSz cx="6858000" cy="12192000"/>
+  <p:notesMasterIdLst>
+    <p:notesMasterId r:id="rId11"/>
+  </p:notesMasterIdLst>
+  <p:sldSz cx="12191695" cy="6858000"/>
+  <p:notesSz cx="6858000" cy="12191695"/>
   <p:defaultTextStyle>
     <a:lvl1pPr marL="0" algn="l" defTabSz="914400" rtl="0" eaLnBrk="1" latinLnBrk="0" hangingPunct="1">
       <a:defRPr sz="1800" kern="1200">
@@ -112,11 +112,6 @@
       </a:defRPr>
     </a:lvl9pPr>
   </p:defaultTextStyle>
-  <p:extLst>
-    <p:ext uri="{EFAFB233-063F-42B5-8137-9DF3F51BA10A}">
-      <p15:sldGuideLst xmlns:p15="http://schemas.microsoft.com/office/powerpoint/2012/main"/>
-    </p:ext>
-  </p:extLst>
 </p:presentation>
 </file>
 
@@ -142,10 +137,234 @@
           <a:chExt cx="0" cy="0"/>
         </a:xfrm>
       </p:grpSpPr>
+      <p:sp>
+        <p:nvSpPr>
+          <p:cNvPr id="2" name="Header Placeholder 1"/>
+          <p:cNvSpPr>
+            <a:spLocks noGrp="1"/>
+          </p:cNvSpPr>
+          <p:nvPr>
+            <p:ph type="hdr" sz="quarter"/>
+          </p:nvPr>
+        </p:nvSpPr>
+        <p:spPr>
+          <a:xfrm>
+            <a:off x="0" y="0"/>
+            <a:ext cx="2971800" cy="458788"/>
+          </a:xfrm>
+          <a:prstGeom prst="rect">
+            <a:avLst/>
+          </a:prstGeom>
+        </p:spPr>
+        <p:txBody>
+          <a:bodyPr vert="horz" lIns="91440" tIns="45720" rIns="91440" bIns="45720" rtlCol="0"/>
+          <a:lstStyle>
+            <a:lvl1pPr algn="l">
+              <a:defRPr sz="1200"/>
+            </a:lvl1pPr>
+          </a:lstStyle>
+          <a:p>
+            <a:endParaRPr lang="en-US"/>
+          </a:p>
+        </p:txBody>
+      </p:sp>
+      <p:sp>
+        <p:nvSpPr>
+          <p:cNvPr id="3" name="Date Placeholder 2"/>
+          <p:cNvSpPr>
+            <a:spLocks noGrp="1"/>
+          </p:cNvSpPr>
+          <p:nvPr>
+            <p:ph type="dt" idx="1"/>
+          </p:nvPr>
+        </p:nvSpPr>
+        <p:spPr>
+          <a:xfrm>
+            <a:off x="3884613" y="0"/>
+            <a:ext cx="2971800" cy="458788"/>
+          </a:xfrm>
+          <a:prstGeom prst="rect">
+            <a:avLst/>
+          </a:prstGeom>
+        </p:spPr>
+        <p:txBody>
+          <a:bodyPr vert="horz" lIns="91440" tIns="45720" rIns="91440" bIns="45720" rtlCol="0"/>
+          <a:lstStyle>
+            <a:lvl1pPr algn="r">
+              <a:defRPr sz="1200"/>
+            </a:lvl1pPr>
+          </a:lstStyle>
+          <a:p>
+            <a:fld id="{5282F153-3F37-0F45-9E97-73ACFA13230C}" type="datetimeFigureOut">
+              <a:rPr lang="en-US"/>
+              <a:t>7/23/19</a:t>
+            </a:fld>
+            <a:endParaRPr lang="en-US"/>
+          </a:p>
+        </p:txBody>
+      </p:sp>
+      <p:sp>
+        <p:nvSpPr>
+          <p:cNvPr id="4" name="Slide Image Placeholder 3"/>
+          <p:cNvSpPr>
+            <a:spLocks noGrp="1" noRot="1" noChangeAspect="1"/>
+          </p:cNvSpPr>
+          <p:nvPr>
+            <p:ph type="sldImg" idx="2"/>
+          </p:nvPr>
+        </p:nvSpPr>
+        <p:spPr>
+          <a:xfrm>
+            <a:off x="685800" y="1143000"/>
+            <a:ext cx="5486400" cy="3086100"/>
+          </a:xfrm>
+          <a:prstGeom prst="rect">
+            <a:avLst/>
+          </a:prstGeom>
+          <a:noFill/>
+          <a:ln w="12700">
+            <a:solidFill>
+              <a:prstClr val="black"/>
+            </a:solidFill>
+          </a:ln>
+        </p:spPr>
+        <p:txBody>
+          <a:bodyPr vert="horz" lIns="91440" tIns="45720" rIns="91440" bIns="45720" rtlCol="0" anchor="ctr"/>
+          <a:lstStyle/>
+          <a:p>
+            <a:endParaRPr lang="en-US"/>
+          </a:p>
+        </p:txBody>
+      </p:sp>
+      <p:sp>
+        <p:nvSpPr>
+          <p:cNvPr id="5" name="Notes Placeholder 4"/>
+          <p:cNvSpPr>
+            <a:spLocks noGrp="1"/>
+          </p:cNvSpPr>
+          <p:nvPr>
+            <p:ph type="body" sz="quarter" idx="3"/>
+          </p:nvPr>
+        </p:nvSpPr>
+        <p:spPr>
+          <a:xfrm>
+            <a:off x="685800" y="4400550"/>
+            <a:ext cx="5486400" cy="3600450"/>
+          </a:xfrm>
+          <a:prstGeom prst="rect">
+            <a:avLst/>
+          </a:prstGeom>
+        </p:spPr>
+        <p:txBody>
+          <a:bodyPr vert="horz" lIns="91440" tIns="45720" rIns="91440" bIns="45720" rtlCol="0"/>
+          <a:lstStyle/>
+          <a:p>
+            <a:pPr lvl="0"/>
+            <a:r>
+              <a:rPr lang="en-US"/>
+              <a:t>Click to edit Master text styles</a:t>
+            </a:r>
+          </a:p>
+          <a:p>
+            <a:pPr lvl="1"/>
+            <a:r>
+              <a:rPr lang="en-US"/>
+              <a:t>Second level</a:t>
+            </a:r>
+          </a:p>
+          <a:p>
+            <a:pPr lvl="2"/>
+            <a:r>
+              <a:rPr lang="en-US"/>
+              <a:t>Third level</a:t>
+            </a:r>
+          </a:p>
+          <a:p>
+            <a:pPr lvl="3"/>
+            <a:r>
+              <a:rPr lang="en-US"/>
+              <a:t>Fourth level</a:t>
+            </a:r>
+          </a:p>
+          <a:p>
+            <a:pPr lvl="4"/>
+            <a:r>
+              <a:rPr lang="en-US"/>
+              <a:t>Fifth level</a:t>
+            </a:r>
+          </a:p>
+        </p:txBody>
+      </p:sp>
+      <p:sp>
+        <p:nvSpPr>
+          <p:cNvPr id="6" name="Footer Placeholder 5"/>
+          <p:cNvSpPr>
+            <a:spLocks noGrp="1"/>
+          </p:cNvSpPr>
+          <p:nvPr>
+            <p:ph type="ftr" sz="quarter" idx="4"/>
+          </p:nvPr>
+        </p:nvSpPr>
+        <p:spPr>
+          <a:xfrm>
+            <a:off x="0" y="8685213"/>
+            <a:ext cx="2971800" cy="458787"/>
+          </a:xfrm>
+          <a:prstGeom prst="rect">
+            <a:avLst/>
+          </a:prstGeom>
+        </p:spPr>
+        <p:txBody>
+          <a:bodyPr vert="horz" lIns="91440" tIns="45720" rIns="91440" bIns="45720" rtlCol="0" anchor="b"/>
+          <a:lstStyle>
+            <a:lvl1pPr algn="l">
+              <a:defRPr sz="1200"/>
+            </a:lvl1pPr>
+          </a:lstStyle>
+          <a:p>
+            <a:endParaRPr lang="en-US"/>
+          </a:p>
+        </p:txBody>
+      </p:sp>
+      <p:sp>
+        <p:nvSpPr>
+          <p:cNvPr id="7" name="Slide Number Placeholder 6"/>
+          <p:cNvSpPr>
+            <a:spLocks noGrp="1"/>
+          </p:cNvSpPr>
+          <p:nvPr>
+            <p:ph type="sldNum" sz="quarter" idx="5"/>
+          </p:nvPr>
+        </p:nvSpPr>
+        <p:spPr>
+          <a:xfrm>
+            <a:off x="3884613" y="8685213"/>
+            <a:ext cx="2971800" cy="458787"/>
+          </a:xfrm>
+          <a:prstGeom prst="rect">
+            <a:avLst/>
+          </a:prstGeom>
+        </p:spPr>
+        <p:txBody>
+          <a:bodyPr vert="horz" lIns="91440" tIns="45720" rIns="91440" bIns="45720" rtlCol="0" anchor="b"/>
+          <a:lstStyle>
+            <a:lvl1pPr algn="r">
+              <a:defRPr sz="1200"/>
+            </a:lvl1pPr>
+          </a:lstStyle>
+          <a:p>
+            <a:fld id="{CE5E9CC1-C706-0F49-92D6-E571CC5EEA8F}" type="slidenum">
+              <a:rPr lang="en-US"/>
+              <a:t>‹#›</a:t>
+            </a:fld>
+            <a:endParaRPr lang="en-US"/>
+          </a:p>
+        </p:txBody>
+      </p:sp>
     </p:spTree>
     <p:extLst>
       <p:ext uri="{BB962C8B-B14F-4D97-AF65-F5344CB8AC3E}">
-        <p14:creationId xmlns:p14="http://schemas.microsoft.com/office/powerpoint/2010/main" val="2306779157"/>
+        <p14:creationId xmlns:p14="http://schemas.microsoft.com/office/powerpoint/2010/main" val="1024086991"/>
       </p:ext>
     </p:extLst>
   </p:cSld>
@@ -289,6 +508,10 @@
           <a:bodyPr/>
           <a:lstStyle/>
           <a:p>
+            <a:r>
+              <a:rPr lang="en-US" dirty="0"/>
+              <a:t/>
+            </a:r>
             <a:endParaRPr lang="en-US" dirty="0"/>
           </a:p>
         </p:txBody>
@@ -373,6 +596,10 @@
           <a:bodyPr/>
           <a:lstStyle/>
           <a:p>
+            <a:r>
+              <a:rPr lang="en-US" dirty="0"/>
+              <a:t/>
+            </a:r>
             <a:endParaRPr lang="en-US" dirty="0"/>
           </a:p>
         </p:txBody>
@@ -457,6 +684,10 @@
           <a:bodyPr/>
           <a:lstStyle/>
           <a:p>
+            <a:r>
+              <a:rPr lang="en-US" dirty="0"/>
+              <a:t/>
+            </a:r>
             <a:endParaRPr lang="en-US" dirty="0"/>
           </a:p>
         </p:txBody>
@@ -541,6 +772,10 @@
           <a:bodyPr/>
           <a:lstStyle/>
           <a:p>
+            <a:r>
+              <a:rPr lang="en-US" dirty="0"/>
+              <a:t/>
+            </a:r>
             <a:endParaRPr lang="en-US" dirty="0"/>
           </a:p>
         </p:txBody>
@@ -625,6 +860,10 @@
           <a:bodyPr/>
           <a:lstStyle/>
           <a:p>
+            <a:r>
+              <a:rPr lang="en-US" dirty="0"/>
+              <a:t/>
+            </a:r>
             <a:endParaRPr lang="en-US" dirty="0"/>
           </a:p>
         </p:txBody>
@@ -709,6 +948,10 @@
           <a:bodyPr/>
           <a:lstStyle/>
           <a:p>
+            <a:r>
+              <a:rPr lang="en-US" dirty="0"/>
+              <a:t/>
+            </a:r>
             <a:endParaRPr lang="en-US" dirty="0"/>
           </a:p>
         </p:txBody>
@@ -793,6 +1036,10 @@
           <a:bodyPr/>
           <a:lstStyle/>
           <a:p>
+            <a:r>
+              <a:rPr lang="en-US" dirty="0"/>
+              <a:t/>
+            </a:r>
             <a:endParaRPr lang="en-US" dirty="0"/>
           </a:p>
         </p:txBody>
@@ -877,6 +1124,10 @@
           <a:bodyPr/>
           <a:lstStyle/>
           <a:p>
+            <a:r>
+              <a:rPr lang="en-US" dirty="0"/>
+              <a:t/>
+            </a:r>
             <a:endParaRPr lang="en-US" dirty="0"/>
           </a:p>
         </p:txBody>
@@ -961,6 +1212,10 @@
           <a:bodyPr/>
           <a:lstStyle/>
           <a:p>
+            <a:r>
+              <a:rPr lang="en-US" dirty="0"/>
+              <a:t/>
+            </a:r>
             <a:endParaRPr lang="en-US" dirty="0"/>
           </a:p>
         </p:txBody>
@@ -1034,11 +1289,6 @@
 <file path=ppt/slideMasters/slideMaster1.xml><?xml version="1.0" encoding="utf-8"?>
 <p:sldMaster xmlns:a="http://schemas.openxmlformats.org/drawingml/2006/main" xmlns:r="http://schemas.openxmlformats.org/officeDocument/2006/relationships" xmlns:p="http://schemas.openxmlformats.org/presentationml/2006/main">
   <p:cSld>
-    <p:bg>
-      <p:bgRef idx="1001">
-        <a:schemeClr val="bg1"/>
-      </p:bgRef>
-    </p:bg>
     <p:spTree>
       <p:nvGrpSpPr>
         <p:cNvPr id="1" name=""/>
@@ -1321,7 +1571,6 @@
         <a:solidFill>
           <a:srgbClr val="120F22"/>
         </a:solidFill>
-        <a:effectLst/>
       </p:bgPr>
     </p:bg>
     <p:spTree>
@@ -1359,13 +1608,6 @@
           </a:solidFill>
           <a:ln/>
         </p:spPr>
-        <p:txBody>
-          <a:bodyPr/>
-          <a:lstStyle/>
-          <a:p>
-            <a:endParaRPr lang="zh-CN" altLang="en-US"/>
-          </a:p>
-        </p:txBody>
       </p:sp>
       <p:sp>
         <p:nvSpPr>
@@ -1388,13 +1630,6 @@
           </a:solidFill>
           <a:ln/>
         </p:spPr>
-        <p:txBody>
-          <a:bodyPr/>
-          <a:lstStyle/>
-          <a:p>
-            <a:endParaRPr lang="zh-CN" altLang="en-US"/>
-          </a:p>
-        </p:txBody>
       </p:sp>
       <p:sp>
         <p:nvSpPr>
@@ -1417,7 +1652,7 @@
           <a:bodyPr wrap="square" rtlCol="0" anchor="ctr"/>
           <a:lstStyle/>
           <a:p>
-            <a:pPr marL="0" indent="0" algn="l">
+            <a:pPr algn="l" indent="0" marL="0">
               <a:buNone/>
             </a:pPr>
             <a:r>
@@ -1431,6 +1666,9 @@
               </a:rPr>
               <a:t>● </a:t>
             </a:r>
+            <a:pPr algn="l" indent="0" marL="0">
+              <a:buNone/>
+            </a:pPr>
             <a:r>
               <a:rPr lang="en-US" sz="1200" b="1" dirty="0">
                 <a:solidFill>
@@ -1467,7 +1705,7 @@
           <a:bodyPr wrap="square" lIns="0" tIns="0" rIns="0" bIns="0" rtlCol="0" anchor="ctr"/>
           <a:lstStyle/>
           <a:p>
-            <a:pPr marL="0" indent="0" algn="l">
+            <a:pPr algn="l" indent="0" marL="0">
               <a:lnSpc>
                 <a:spcPct val="98000"/>
               </a:lnSpc>
@@ -1487,7 +1725,7 @@
             <a:endParaRPr lang="en-US" sz="4600" dirty="0"/>
           </a:p>
           <a:p>
-            <a:pPr marL="0" indent="0" algn="l">
+            <a:pPr algn="l" indent="0" marL="0">
               <a:lnSpc>
                 <a:spcPct val="98000"/>
               </a:lnSpc>
@@ -1529,7 +1767,7 @@
           <a:bodyPr wrap="square" rtlCol="0" anchor="ctr"/>
           <a:lstStyle/>
           <a:p>
-            <a:pPr marL="0" indent="0" algn="l">
+            <a:pPr algn="l" indent="0" marL="0">
               <a:lnSpc>
                 <a:spcPct val="105000"/>
               </a:lnSpc>
@@ -1571,7 +1809,7 @@
           <a:bodyPr wrap="square" rtlCol="0" anchor="ctr"/>
           <a:lstStyle/>
           <a:p>
-            <a:pPr marL="0" indent="0" algn="l">
+            <a:pPr algn="l" indent="0" marL="0">
               <a:buNone/>
             </a:pPr>
             <a:r>
@@ -1615,13 +1853,6 @@
             <a:prstDash val="solid"/>
           </a:ln>
         </p:spPr>
-        <p:txBody>
-          <a:bodyPr/>
-          <a:lstStyle/>
-          <a:p>
-            <a:endParaRPr lang="zh-CN" altLang="en-US"/>
-          </a:p>
-        </p:txBody>
       </p:sp>
       <p:sp>
         <p:nvSpPr>
@@ -1644,7 +1875,7 @@
           <a:bodyPr wrap="square" lIns="0" tIns="0" rIns="0" bIns="0" rtlCol="0" anchor="ctr"/>
           <a:lstStyle/>
           <a:p>
-            <a:pPr marL="0" indent="0" algn="ctr">
+            <a:pPr algn="ctr" indent="0" marL="0">
               <a:buNone/>
             </a:pPr>
             <a:r>
@@ -1688,13 +1919,6 @@
             <a:prstDash val="solid"/>
           </a:ln>
         </p:spPr>
-        <p:txBody>
-          <a:bodyPr/>
-          <a:lstStyle/>
-          <a:p>
-            <a:endParaRPr lang="zh-CN" altLang="en-US"/>
-          </a:p>
-        </p:txBody>
       </p:sp>
       <p:sp>
         <p:nvSpPr>
@@ -1717,7 +1941,7 @@
           <a:bodyPr wrap="square" lIns="0" tIns="0" rIns="0" bIns="0" rtlCol="0" anchor="ctr"/>
           <a:lstStyle/>
           <a:p>
-            <a:pPr marL="0" indent="0" algn="ctr">
+            <a:pPr algn="ctr" indent="0" marL="0">
               <a:buNone/>
             </a:pPr>
             <a:r>
@@ -1761,13 +1985,6 @@
             <a:prstDash val="solid"/>
           </a:ln>
         </p:spPr>
-        <p:txBody>
-          <a:bodyPr/>
-          <a:lstStyle/>
-          <a:p>
-            <a:endParaRPr lang="zh-CN" altLang="en-US"/>
-          </a:p>
-        </p:txBody>
       </p:sp>
       <p:sp>
         <p:nvSpPr>
@@ -1790,7 +2007,7 @@
           <a:bodyPr wrap="square" lIns="0" tIns="0" rIns="0" bIns="0" rtlCol="0" anchor="ctr"/>
           <a:lstStyle/>
           <a:p>
-            <a:pPr marL="0" indent="0" algn="ctr">
+            <a:pPr algn="ctr" indent="0" marL="0">
               <a:buNone/>
             </a:pPr>
             <a:r>
@@ -1802,7 +2019,7 @@
                 <a:ea typeface="Segoe UI Semibold" pitchFamily="34" charset="-122"/>
                 <a:cs typeface="Segoe UI Semibold" pitchFamily="34" charset="-120"/>
               </a:rPr>
-              <a:t>4 languages</a:t>
+              <a:t>6 languages</a:t>
             </a:r>
             <a:endParaRPr lang="en-US" sz="1200" dirty="0"/>
           </a:p>
@@ -1834,13 +2051,6 @@
             <a:prstDash val="solid"/>
           </a:ln>
         </p:spPr>
-        <p:txBody>
-          <a:bodyPr/>
-          <a:lstStyle/>
-          <a:p>
-            <a:endParaRPr lang="zh-CN" altLang="en-US"/>
-          </a:p>
-        </p:txBody>
       </p:sp>
       <p:sp>
         <p:nvSpPr>
@@ -1863,7 +2073,7 @@
           <a:bodyPr wrap="square" lIns="0" tIns="0" rIns="0" bIns="0" rtlCol="0" anchor="ctr"/>
           <a:lstStyle/>
           <a:p>
-            <a:pPr marL="0" indent="0" algn="ctr">
+            <a:pPr algn="ctr" indent="0" marL="0">
               <a:buNone/>
             </a:pPr>
             <a:r>
@@ -1883,14 +2093,14 @@
       </p:sp>
       <p:pic>
         <p:nvPicPr>
-          <p:cNvPr id="16" name="Image 0" descr="C:\D365DEMO\__Projects\Agent JumpStart 2\promo\img\cover-en.png"/>
+          <p:cNvPr id="16" name="Image 0" descr="C:\D365DEMO\__Projects\Agent JumpStart 2\promo\img\cover-en.png">    </p:cNvPr>
           <p:cNvPicPr>
             <a:picLocks noChangeAspect="1"/>
           </p:cNvPicPr>
           <p:nvPr/>
         </p:nvPicPr>
         <p:blipFill>
-          <a:blip r:embed="rId3"/>
+          <a:blip r:embed="rId1"/>
           <a:stretch>
             <a:fillRect/>
           </a:stretch>
@@ -1928,13 +2138,6 @@
             <a:prstDash val="solid"/>
           </a:ln>
         </p:spPr>
-        <p:txBody>
-          <a:bodyPr/>
-          <a:lstStyle/>
-          <a:p>
-            <a:endParaRPr lang="zh-CN" altLang="en-US"/>
-          </a:p>
-        </p:txBody>
       </p:sp>
     </p:spTree>
   </p:cSld>
@@ -1952,7 +2155,6 @@
         <a:solidFill>
           <a:srgbClr val="181334"/>
         </a:solidFill>
-        <a:effectLst/>
       </p:bgPr>
     </p:bg>
     <p:spTree>
@@ -1990,11 +2192,11 @@
           <a:bodyPr wrap="square" lIns="0" tIns="0" rIns="0" bIns="0" rtlCol="0" anchor="ctr"/>
           <a:lstStyle/>
           <a:p>
-            <a:pPr marL="0" indent="0" algn="l">
-              <a:buNone/>
-            </a:pPr>
-            <a:r>
-              <a:rPr lang="en-US" sz="1250" b="1" kern="0" spc="300" dirty="0">
+            <a:pPr algn="l" indent="0" marL="0">
+              <a:buNone/>
+            </a:pPr>
+            <a:r>
+              <a:rPr lang="en-US" sz="1250" b="1" spc="300" kern="0" dirty="0">
                 <a:solidFill>
                   <a:srgbClr val="A78BFA"/>
                 </a:solidFill>
@@ -2029,7 +2231,7 @@
           <a:bodyPr wrap="square" lIns="0" tIns="0" rIns="0" bIns="0" rtlCol="0" anchor="ctr"/>
           <a:lstStyle/>
           <a:p>
-            <a:pPr marL="0" indent="0" algn="l">
+            <a:pPr algn="l" indent="0" marL="0">
               <a:buNone/>
             </a:pPr>
             <a:r>
@@ -2043,6 +2245,9 @@
               </a:rPr>
               <a:t>A workshop that runs itself — </a:t>
             </a:r>
+            <a:pPr algn="l" indent="0" marL="0">
+              <a:buNone/>
+            </a:pPr>
             <a:r>
               <a:rPr lang="en-US" sz="3300" b="1" dirty="0">
                 <a:solidFill>
@@ -2054,6 +2259,9 @@
               </a:rPr>
               <a:t>learners just press play</a:t>
             </a:r>
+            <a:pPr algn="l" indent="0" marL="0">
+              <a:buNone/>
+            </a:pPr>
             <a:r>
               <a:rPr lang="en-US" sz="3300" b="1" dirty="0">
                 <a:solidFill>
@@ -2090,7 +2298,7 @@
           <a:bodyPr wrap="square" rtlCol="0" anchor="ctr"/>
           <a:lstStyle/>
           <a:p>
-            <a:pPr marL="0" indent="0" algn="l">
+            <a:pPr algn="l" indent="0" marL="0">
               <a:lnSpc>
                 <a:spcPct val="118000"/>
               </a:lnSpc>
@@ -2130,13 +2338,6 @@
           </a:solidFill>
           <a:ln/>
         </p:spPr>
-        <p:txBody>
-          <a:bodyPr/>
-          <a:lstStyle/>
-          <a:p>
-            <a:endParaRPr lang="zh-CN" altLang="en-US"/>
-          </a:p>
-        </p:txBody>
       </p:sp>
       <p:sp>
         <p:nvSpPr>
@@ -2159,7 +2360,7 @@
           <a:bodyPr wrap="square" lIns="0" tIns="0" rIns="0" bIns="0" rtlCol="0" anchor="t"/>
           <a:lstStyle/>
           <a:p>
-            <a:pPr marL="0" indent="0" algn="l">
+            <a:pPr algn="l" indent="0" marL="0">
               <a:buNone/>
             </a:pPr>
             <a:r>
@@ -2196,13 +2397,6 @@
           </a:solidFill>
           <a:ln/>
         </p:spPr>
-        <p:txBody>
-          <a:bodyPr/>
-          <a:lstStyle/>
-          <a:p>
-            <a:endParaRPr lang="zh-CN" altLang="en-US"/>
-          </a:p>
-        </p:txBody>
       </p:sp>
       <p:sp>
         <p:nvSpPr>
@@ -2225,7 +2419,7 @@
           <a:bodyPr wrap="square" lIns="0" tIns="0" rIns="0" bIns="0" rtlCol="0" anchor="t"/>
           <a:lstStyle/>
           <a:p>
-            <a:pPr marL="0" indent="0" algn="l">
+            <a:pPr algn="l" indent="0" marL="0">
               <a:buNone/>
             </a:pPr>
             <a:r>
@@ -2262,13 +2456,6 @@
           </a:solidFill>
           <a:ln/>
         </p:spPr>
-        <p:txBody>
-          <a:bodyPr/>
-          <a:lstStyle/>
-          <a:p>
-            <a:endParaRPr lang="zh-CN" altLang="en-US"/>
-          </a:p>
-        </p:txBody>
       </p:sp>
       <p:sp>
         <p:nvSpPr>
@@ -2291,7 +2478,7 @@
           <a:bodyPr wrap="square" lIns="0" tIns="0" rIns="0" bIns="0" rtlCol="0" anchor="t"/>
           <a:lstStyle/>
           <a:p>
-            <a:pPr marL="0" indent="0" algn="l">
+            <a:pPr algn="l" indent="0" marL="0">
               <a:buNone/>
             </a:pPr>
             <a:r>
@@ -2335,13 +2522,6 @@
             <a:prstDash val="solid"/>
           </a:ln>
         </p:spPr>
-        <p:txBody>
-          <a:bodyPr/>
-          <a:lstStyle/>
-          <a:p>
-            <a:endParaRPr lang="zh-CN" altLang="en-US"/>
-          </a:p>
-        </p:txBody>
       </p:sp>
       <p:sp>
         <p:nvSpPr>
@@ -2364,7 +2544,7 @@
           <a:bodyPr wrap="square" lIns="0" tIns="0" rIns="0" bIns="0" rtlCol="0" anchor="ctr"/>
           <a:lstStyle/>
           <a:p>
-            <a:pPr marL="0" indent="0" algn="ctr">
+            <a:pPr algn="ctr" indent="0" marL="0">
               <a:buNone/>
             </a:pPr>
             <a:r>
@@ -2400,7 +2580,7 @@
           <a:bodyPr wrap="square" lIns="0" tIns="0" rIns="0" bIns="0" rtlCol="0" anchor="ctr"/>
           <a:lstStyle/>
           <a:p>
-            <a:pPr marL="0" indent="0" algn="ctr">
+            <a:pPr algn="ctr" indent="0" marL="0">
               <a:buNone/>
             </a:pPr>
             <a:r>
@@ -2439,7 +2619,7 @@
           <a:bodyPr wrap="square" lIns="0" tIns="0" rIns="0" bIns="0" rtlCol="0" anchor="ctr"/>
           <a:lstStyle/>
           <a:p>
-            <a:pPr marL="0" indent="0" algn="ctr">
+            <a:pPr algn="ctr" indent="0" marL="0">
               <a:buNone/>
             </a:pPr>
             <a:r>
@@ -2483,13 +2663,6 @@
             <a:prstDash val="solid"/>
           </a:ln>
         </p:spPr>
-        <p:txBody>
-          <a:bodyPr/>
-          <a:lstStyle/>
-          <a:p>
-            <a:endParaRPr lang="zh-CN" altLang="en-US"/>
-          </a:p>
-        </p:txBody>
       </p:sp>
       <p:sp>
         <p:nvSpPr>
@@ -2512,7 +2685,7 @@
           <a:bodyPr wrap="square" lIns="0" tIns="0" rIns="0" bIns="0" rtlCol="0" anchor="ctr"/>
           <a:lstStyle/>
           <a:p>
-            <a:pPr marL="0" indent="0" algn="ctr">
+            <a:pPr algn="ctr" indent="0" marL="0">
               <a:buNone/>
             </a:pPr>
             <a:r>
@@ -2548,7 +2721,7 @@
           <a:bodyPr wrap="square" lIns="0" tIns="0" rIns="0" bIns="0" rtlCol="0" anchor="ctr"/>
           <a:lstStyle/>
           <a:p>
-            <a:pPr marL="0" indent="0" algn="ctr">
+            <a:pPr algn="ctr" indent="0" marL="0">
               <a:buNone/>
             </a:pPr>
             <a:r>
@@ -2587,7 +2760,7 @@
           <a:bodyPr wrap="square" lIns="0" tIns="0" rIns="0" bIns="0" rtlCol="0" anchor="ctr"/>
           <a:lstStyle/>
           <a:p>
-            <a:pPr marL="0" indent="0" algn="ctr">
+            <a:pPr algn="ctr" indent="0" marL="0">
               <a:buNone/>
             </a:pPr>
             <a:r>
@@ -2631,13 +2804,6 @@
             <a:prstDash val="solid"/>
           </a:ln>
         </p:spPr>
-        <p:txBody>
-          <a:bodyPr/>
-          <a:lstStyle/>
-          <a:p>
-            <a:endParaRPr lang="zh-CN" altLang="en-US"/>
-          </a:p>
-        </p:txBody>
       </p:sp>
       <p:sp>
         <p:nvSpPr>
@@ -2660,7 +2826,7 @@
           <a:bodyPr wrap="square" lIns="0" tIns="0" rIns="0" bIns="0" rtlCol="0" anchor="ctr"/>
           <a:lstStyle/>
           <a:p>
-            <a:pPr marL="0" indent="0" algn="ctr">
+            <a:pPr algn="ctr" indent="0" marL="0">
               <a:buNone/>
             </a:pPr>
             <a:r>
@@ -2696,7 +2862,7 @@
           <a:bodyPr wrap="square" lIns="0" tIns="0" rIns="0" bIns="0" rtlCol="0" anchor="ctr"/>
           <a:lstStyle/>
           <a:p>
-            <a:pPr marL="0" indent="0" algn="ctr">
+            <a:pPr algn="ctr" indent="0" marL="0">
               <a:buNone/>
             </a:pPr>
             <a:r>
@@ -2708,7 +2874,7 @@
                 <a:ea typeface="Segoe UI Semibold" pitchFamily="34" charset="-122"/>
                 <a:cs typeface="Segoe UI Semibold" pitchFamily="34" charset="-120"/>
               </a:rPr>
-              <a:t>4</a:t>
+              <a:t>6</a:t>
             </a:r>
             <a:endParaRPr lang="en-US" sz="5000" dirty="0"/>
           </a:p>
@@ -2735,7 +2901,7 @@
           <a:bodyPr wrap="square" lIns="0" tIns="0" rIns="0" bIns="0" rtlCol="0" anchor="ctr"/>
           <a:lstStyle/>
           <a:p>
-            <a:pPr marL="0" indent="0" algn="ctr">
+            <a:pPr algn="ctr" indent="0" marL="0">
               <a:buNone/>
             </a:pPr>
             <a:r>
@@ -2779,13 +2945,6 @@
             <a:prstDash val="solid"/>
           </a:ln>
         </p:spPr>
-        <p:txBody>
-          <a:bodyPr/>
-          <a:lstStyle/>
-          <a:p>
-            <a:endParaRPr lang="zh-CN" altLang="en-US"/>
-          </a:p>
-        </p:txBody>
       </p:sp>
       <p:sp>
         <p:nvSpPr>
@@ -2808,7 +2967,7 @@
           <a:bodyPr wrap="square" lIns="0" tIns="0" rIns="0" bIns="0" rtlCol="0" anchor="ctr"/>
           <a:lstStyle/>
           <a:p>
-            <a:pPr marL="0" indent="0" algn="ctr">
+            <a:pPr algn="ctr" indent="0" marL="0">
               <a:buNone/>
             </a:pPr>
             <a:r>
@@ -2844,7 +3003,7 @@
           <a:bodyPr wrap="square" lIns="0" tIns="0" rIns="0" bIns="0" rtlCol="0" anchor="ctr"/>
           <a:lstStyle/>
           <a:p>
-            <a:pPr marL="0" indent="0" algn="ctr">
+            <a:pPr algn="ctr" indent="0" marL="0">
               <a:buNone/>
             </a:pPr>
             <a:r>
@@ -2883,7 +3042,7 @@
           <a:bodyPr wrap="square" lIns="0" tIns="0" rIns="0" bIns="0" rtlCol="0" anchor="ctr"/>
           <a:lstStyle/>
           <a:p>
-            <a:pPr marL="0" indent="0" algn="ctr">
+            <a:pPr algn="ctr" indent="0" marL="0">
               <a:buNone/>
             </a:pPr>
             <a:r>
@@ -2917,7 +3076,6 @@
         <a:solidFill>
           <a:srgbClr val="120F22"/>
         </a:solidFill>
-        <a:effectLst/>
       </p:bgPr>
     </p:bg>
     <p:spTree>
@@ -2955,11 +3113,11 @@
           <a:bodyPr wrap="square" lIns="0" tIns="0" rIns="0" bIns="0" rtlCol="0" anchor="ctr"/>
           <a:lstStyle/>
           <a:p>
-            <a:pPr marL="0" indent="0" algn="l">
-              <a:buNone/>
-            </a:pPr>
-            <a:r>
-              <a:rPr lang="en-US" sz="1250" b="1" kern="0" spc="300" dirty="0">
+            <a:pPr algn="l" indent="0" marL="0">
+              <a:buNone/>
+            </a:pPr>
+            <a:r>
+              <a:rPr lang="en-US" sz="1250" b="1" spc="300" kern="0" dirty="0">
                 <a:solidFill>
                   <a:srgbClr val="A78BFA"/>
                 </a:solidFill>
@@ -2994,7 +3152,7 @@
           <a:bodyPr wrap="square" lIns="0" tIns="0" rIns="0" bIns="0" rtlCol="0" anchor="ctr"/>
           <a:lstStyle/>
           <a:p>
-            <a:pPr marL="0" indent="0" algn="l">
+            <a:pPr algn="l" indent="0" marL="0">
               <a:buNone/>
             </a:pPr>
             <a:r>
@@ -3008,6 +3166,9 @@
               </a:rPr>
               <a:t>Six labs, from first agent to </a:t>
             </a:r>
+            <a:pPr algn="l" indent="0" marL="0">
+              <a:buNone/>
+            </a:pPr>
             <a:r>
               <a:rPr lang="en-US" sz="3300" b="1" dirty="0">
                 <a:solidFill>
@@ -3019,6 +3180,9 @@
               </a:rPr>
               <a:t>real-time voice</a:t>
             </a:r>
+            <a:pPr algn="l" indent="0" marL="0">
+              <a:buNone/>
+            </a:pPr>
             <a:r>
               <a:rPr lang="en-US" sz="3300" b="1" dirty="0">
                 <a:solidFill>
@@ -3060,13 +3224,6 @@
             <a:prstDash val="solid"/>
           </a:ln>
         </p:spPr>
-        <p:txBody>
-          <a:bodyPr/>
-          <a:lstStyle/>
-          <a:p>
-            <a:endParaRPr lang="zh-CN" altLang="en-US"/>
-          </a:p>
-        </p:txBody>
       </p:sp>
       <p:sp>
         <p:nvSpPr>
@@ -3089,7 +3246,7 @@
           <a:bodyPr wrap="square" lIns="0" tIns="0" rIns="0" bIns="0" rtlCol="0" anchor="ctr"/>
           <a:lstStyle/>
           <a:p>
-            <a:pPr marL="0" indent="0" algn="r">
+            <a:pPr algn="r" indent="0" marL="0">
               <a:buNone/>
             </a:pPr>
             <a:r>
@@ -3125,7 +3282,7 @@
           <a:bodyPr wrap="square" lIns="0" tIns="0" rIns="0" bIns="0" rtlCol="0" anchor="ctr"/>
           <a:lstStyle/>
           <a:p>
-            <a:pPr marL="0" indent="0">
+            <a:pPr indent="0" marL="0">
               <a:buNone/>
             </a:pPr>
             <a:r>
@@ -3164,7 +3321,7 @@
           <a:bodyPr wrap="square" lIns="0" tIns="0" rIns="0" bIns="0" rtlCol="0" anchor="ctr"/>
           <a:lstStyle/>
           <a:p>
-            <a:pPr marL="0" indent="0">
+            <a:pPr indent="0" marL="0">
               <a:buNone/>
             </a:pPr>
             <a:r>
@@ -3203,7 +3360,7 @@
           <a:bodyPr wrap="square" lIns="0" tIns="0" rIns="0" bIns="0" rtlCol="0" anchor="ctr"/>
           <a:lstStyle/>
           <a:p>
-            <a:pPr marL="0" indent="0">
+            <a:pPr indent="0" marL="0">
               <a:lnSpc>
                 <a:spcPct val="106000"/>
               </a:lnSpc>
@@ -3250,13 +3407,6 @@
             <a:prstDash val="solid"/>
           </a:ln>
         </p:spPr>
-        <p:txBody>
-          <a:bodyPr/>
-          <a:lstStyle/>
-          <a:p>
-            <a:endParaRPr lang="zh-CN" altLang="en-US"/>
-          </a:p>
-        </p:txBody>
       </p:sp>
       <p:sp>
         <p:nvSpPr>
@@ -3279,7 +3429,7 @@
           <a:bodyPr wrap="square" lIns="0" tIns="0" rIns="0" bIns="0" rtlCol="0" anchor="ctr"/>
           <a:lstStyle/>
           <a:p>
-            <a:pPr marL="0" indent="0" algn="r">
+            <a:pPr algn="r" indent="0" marL="0">
               <a:buNone/>
             </a:pPr>
             <a:r>
@@ -3315,7 +3465,7 @@
           <a:bodyPr wrap="square" lIns="0" tIns="0" rIns="0" bIns="0" rtlCol="0" anchor="ctr"/>
           <a:lstStyle/>
           <a:p>
-            <a:pPr marL="0" indent="0">
+            <a:pPr indent="0" marL="0">
               <a:buNone/>
             </a:pPr>
             <a:r>
@@ -3354,7 +3504,7 @@
           <a:bodyPr wrap="square" lIns="0" tIns="0" rIns="0" bIns="0" rtlCol="0" anchor="ctr"/>
           <a:lstStyle/>
           <a:p>
-            <a:pPr marL="0" indent="0">
+            <a:pPr indent="0" marL="0">
               <a:buNone/>
             </a:pPr>
             <a:r>
@@ -3393,7 +3543,7 @@
           <a:bodyPr wrap="square" lIns="0" tIns="0" rIns="0" bIns="0" rtlCol="0" anchor="ctr"/>
           <a:lstStyle/>
           <a:p>
-            <a:pPr marL="0" indent="0">
+            <a:pPr indent="0" marL="0">
               <a:lnSpc>
                 <a:spcPct val="106000"/>
               </a:lnSpc>
@@ -3440,13 +3590,6 @@
             <a:prstDash val="solid"/>
           </a:ln>
         </p:spPr>
-        <p:txBody>
-          <a:bodyPr/>
-          <a:lstStyle/>
-          <a:p>
-            <a:endParaRPr lang="zh-CN" altLang="en-US"/>
-          </a:p>
-        </p:txBody>
       </p:sp>
       <p:sp>
         <p:nvSpPr>
@@ -3469,7 +3612,7 @@
           <a:bodyPr wrap="square" lIns="0" tIns="0" rIns="0" bIns="0" rtlCol="0" anchor="ctr"/>
           <a:lstStyle/>
           <a:p>
-            <a:pPr marL="0" indent="0" algn="r">
+            <a:pPr algn="r" indent="0" marL="0">
               <a:buNone/>
             </a:pPr>
             <a:r>
@@ -3505,7 +3648,7 @@
           <a:bodyPr wrap="square" lIns="0" tIns="0" rIns="0" bIns="0" rtlCol="0" anchor="ctr"/>
           <a:lstStyle/>
           <a:p>
-            <a:pPr marL="0" indent="0">
+            <a:pPr indent="0" marL="0">
               <a:buNone/>
             </a:pPr>
             <a:r>
@@ -3544,7 +3687,7 @@
           <a:bodyPr wrap="square" lIns="0" tIns="0" rIns="0" bIns="0" rtlCol="0" anchor="ctr"/>
           <a:lstStyle/>
           <a:p>
-            <a:pPr marL="0" indent="0">
+            <a:pPr indent="0" marL="0">
               <a:buNone/>
             </a:pPr>
             <a:r>
@@ -3583,7 +3726,7 @@
           <a:bodyPr wrap="square" lIns="0" tIns="0" rIns="0" bIns="0" rtlCol="0" anchor="ctr"/>
           <a:lstStyle/>
           <a:p>
-            <a:pPr marL="0" indent="0">
+            <a:pPr indent="0" marL="0">
               <a:lnSpc>
                 <a:spcPct val="106000"/>
               </a:lnSpc>
@@ -3630,13 +3773,6 @@
             <a:prstDash val="solid"/>
           </a:ln>
         </p:spPr>
-        <p:txBody>
-          <a:bodyPr/>
-          <a:lstStyle/>
-          <a:p>
-            <a:endParaRPr lang="zh-CN" altLang="en-US"/>
-          </a:p>
-        </p:txBody>
       </p:sp>
       <p:sp>
         <p:nvSpPr>
@@ -3659,7 +3795,7 @@
           <a:bodyPr wrap="square" lIns="0" tIns="0" rIns="0" bIns="0" rtlCol="0" anchor="ctr"/>
           <a:lstStyle/>
           <a:p>
-            <a:pPr marL="0" indent="0" algn="r">
+            <a:pPr algn="r" indent="0" marL="0">
               <a:buNone/>
             </a:pPr>
             <a:r>
@@ -3695,7 +3831,7 @@
           <a:bodyPr wrap="square" lIns="0" tIns="0" rIns="0" bIns="0" rtlCol="0" anchor="ctr"/>
           <a:lstStyle/>
           <a:p>
-            <a:pPr marL="0" indent="0">
+            <a:pPr indent="0" marL="0">
               <a:buNone/>
             </a:pPr>
             <a:r>
@@ -3734,7 +3870,7 @@
           <a:bodyPr wrap="square" lIns="0" tIns="0" rIns="0" bIns="0" rtlCol="0" anchor="ctr"/>
           <a:lstStyle/>
           <a:p>
-            <a:pPr marL="0" indent="0">
+            <a:pPr indent="0" marL="0">
               <a:buNone/>
             </a:pPr>
             <a:r>
@@ -3773,7 +3909,7 @@
           <a:bodyPr wrap="square" lIns="0" tIns="0" rIns="0" bIns="0" rtlCol="0" anchor="ctr"/>
           <a:lstStyle/>
           <a:p>
-            <a:pPr marL="0" indent="0">
+            <a:pPr indent="0" marL="0">
               <a:lnSpc>
                 <a:spcPct val="106000"/>
               </a:lnSpc>
@@ -3820,13 +3956,6 @@
             <a:prstDash val="solid"/>
           </a:ln>
         </p:spPr>
-        <p:txBody>
-          <a:bodyPr/>
-          <a:lstStyle/>
-          <a:p>
-            <a:endParaRPr lang="zh-CN" altLang="en-US"/>
-          </a:p>
-        </p:txBody>
       </p:sp>
       <p:sp>
         <p:nvSpPr>
@@ -3849,7 +3978,7 @@
           <a:bodyPr wrap="square" lIns="0" tIns="0" rIns="0" bIns="0" rtlCol="0" anchor="ctr"/>
           <a:lstStyle/>
           <a:p>
-            <a:pPr marL="0" indent="0" algn="r">
+            <a:pPr algn="r" indent="0" marL="0">
               <a:buNone/>
             </a:pPr>
             <a:r>
@@ -3885,7 +4014,7 @@
           <a:bodyPr wrap="square" lIns="0" tIns="0" rIns="0" bIns="0" rtlCol="0" anchor="ctr"/>
           <a:lstStyle/>
           <a:p>
-            <a:pPr marL="0" indent="0">
+            <a:pPr indent="0" marL="0">
               <a:buNone/>
             </a:pPr>
             <a:r>
@@ -3924,7 +4053,7 @@
           <a:bodyPr wrap="square" lIns="0" tIns="0" rIns="0" bIns="0" rtlCol="0" anchor="ctr"/>
           <a:lstStyle/>
           <a:p>
-            <a:pPr marL="0" indent="0">
+            <a:pPr indent="0" marL="0">
               <a:buNone/>
             </a:pPr>
             <a:r>
@@ -3963,7 +4092,7 @@
           <a:bodyPr wrap="square" lIns="0" tIns="0" rIns="0" bIns="0" rtlCol="0" anchor="ctr"/>
           <a:lstStyle/>
           <a:p>
-            <a:pPr marL="0" indent="0">
+            <a:pPr indent="0" marL="0">
               <a:lnSpc>
                 <a:spcPct val="106000"/>
               </a:lnSpc>
@@ -4010,13 +4139,6 @@
             <a:prstDash val="solid"/>
           </a:ln>
         </p:spPr>
-        <p:txBody>
-          <a:bodyPr/>
-          <a:lstStyle/>
-          <a:p>
-            <a:endParaRPr lang="zh-CN" altLang="en-US"/>
-          </a:p>
-        </p:txBody>
       </p:sp>
       <p:sp>
         <p:nvSpPr>
@@ -4039,7 +4161,7 @@
           <a:bodyPr wrap="square" lIns="0" tIns="0" rIns="0" bIns="0" rtlCol="0" anchor="ctr"/>
           <a:lstStyle/>
           <a:p>
-            <a:pPr marL="0" indent="0" algn="r">
+            <a:pPr algn="r" indent="0" marL="0">
               <a:buNone/>
             </a:pPr>
             <a:r>
@@ -4075,7 +4197,7 @@
           <a:bodyPr wrap="square" lIns="0" tIns="0" rIns="0" bIns="0" rtlCol="0" anchor="ctr"/>
           <a:lstStyle/>
           <a:p>
-            <a:pPr marL="0" indent="0">
+            <a:pPr indent="0" marL="0">
               <a:buNone/>
             </a:pPr>
             <a:r>
@@ -4114,7 +4236,7 @@
           <a:bodyPr wrap="square" lIns="0" tIns="0" rIns="0" bIns="0" rtlCol="0" anchor="ctr"/>
           <a:lstStyle/>
           <a:p>
-            <a:pPr marL="0" indent="0">
+            <a:pPr indent="0" marL="0">
               <a:buNone/>
             </a:pPr>
             <a:r>
@@ -4153,7 +4275,7 @@
           <a:bodyPr wrap="square" lIns="0" tIns="0" rIns="0" bIns="0" rtlCol="0" anchor="ctr"/>
           <a:lstStyle/>
           <a:p>
-            <a:pPr marL="0" indent="0">
+            <a:pPr indent="0" marL="0">
               <a:lnSpc>
                 <a:spcPct val="106000"/>
               </a:lnSpc>
@@ -4190,7 +4312,6 @@
         <a:solidFill>
           <a:srgbClr val="181334"/>
         </a:solidFill>
-        <a:effectLst/>
       </p:bgPr>
     </p:bg>
     <p:spTree>
@@ -4228,11 +4349,11 @@
           <a:bodyPr wrap="square" lIns="0" tIns="0" rIns="0" bIns="0" rtlCol="0" anchor="ctr"/>
           <a:lstStyle/>
           <a:p>
-            <a:pPr marL="0" indent="0" algn="l">
-              <a:buNone/>
-            </a:pPr>
-            <a:r>
-              <a:rPr lang="en-US" sz="1250" b="1" kern="0" spc="300" dirty="0">
+            <a:pPr algn="l" indent="0" marL="0">
+              <a:buNone/>
+            </a:pPr>
+            <a:r>
+              <a:rPr lang="en-US" sz="1250" b="1" spc="300" kern="0" dirty="0">
                 <a:solidFill>
                   <a:srgbClr val="A78BFA"/>
                 </a:solidFill>
@@ -4267,7 +4388,7 @@
           <a:bodyPr wrap="square" lIns="0" tIns="0" rIns="0" bIns="0" rtlCol="0" anchor="ctr"/>
           <a:lstStyle/>
           <a:p>
-            <a:pPr marL="0" indent="0" algn="l">
+            <a:pPr algn="l" indent="0" marL="0">
               <a:buNone/>
             </a:pPr>
             <a:r>
@@ -4281,6 +4402,9 @@
               </a:rPr>
               <a:t>Multilingual </a:t>
             </a:r>
+            <a:pPr algn="l" indent="0" marL="0">
+              <a:buNone/>
+            </a:pPr>
             <a:r>
               <a:rPr lang="en-US" sz="3300" b="1" dirty="0">
                 <a:solidFill>
@@ -4317,7 +4441,7 @@
           <a:bodyPr wrap="square" rtlCol="0" anchor="ctr"/>
           <a:lstStyle/>
           <a:p>
-            <a:pPr marL="0" indent="0" algn="l">
+            <a:pPr algn="l" indent="0" marL="0">
               <a:lnSpc>
                 <a:spcPct val="118000"/>
               </a:lnSpc>
@@ -4332,7 +4456,7 @@
                 <a:ea typeface="Segoe UI" pitchFamily="34" charset="-122"/>
                 <a:cs typeface="Segoe UI" pitchFamily="34" charset="-120"/>
               </a:rPr>
-              <a:t>One click switches the entire experience — cover, labs, instructions, and UI — between English, 中文, 日本語, and 한국어.</a:t>
+              <a:t>One click switches the entire experience — cover, labs, instructions, and UI — between English, 中文, 日本語, 한국어, ไทย, and हिन्दी.</a:t>
             </a:r>
             <a:endParaRPr lang="en-US" sz="2000" dirty="0"/>
           </a:p>
@@ -4357,13 +4481,6 @@
           </a:solidFill>
           <a:ln/>
         </p:spPr>
-        <p:txBody>
-          <a:bodyPr/>
-          <a:lstStyle/>
-          <a:p>
-            <a:endParaRPr lang="zh-CN" altLang="en-US"/>
-          </a:p>
-        </p:txBody>
       </p:sp>
       <p:sp>
         <p:nvSpPr>
@@ -4386,7 +4503,7 @@
           <a:bodyPr wrap="square" lIns="0" tIns="0" rIns="0" bIns="0" rtlCol="0" anchor="ctr"/>
           <a:lstStyle/>
           <a:p>
-            <a:pPr marL="0" indent="0" algn="l">
+            <a:pPr algn="l" indent="0" marL="0">
               <a:buNone/>
             </a:pPr>
             <a:r>
@@ -4423,13 +4540,6 @@
           </a:solidFill>
           <a:ln/>
         </p:spPr>
-        <p:txBody>
-          <a:bodyPr/>
-          <a:lstStyle/>
-          <a:p>
-            <a:endParaRPr lang="zh-CN" altLang="en-US"/>
-          </a:p>
-        </p:txBody>
       </p:sp>
       <p:sp>
         <p:nvSpPr>
@@ -4452,7 +4562,7 @@
           <a:bodyPr wrap="square" lIns="0" tIns="0" rIns="0" bIns="0" rtlCol="0" anchor="ctr"/>
           <a:lstStyle/>
           <a:p>
-            <a:pPr marL="0" indent="0" algn="l">
+            <a:pPr algn="l" indent="0" marL="0">
               <a:buNone/>
             </a:pPr>
             <a:r>
@@ -4489,13 +4599,6 @@
           </a:solidFill>
           <a:ln/>
         </p:spPr>
-        <p:txBody>
-          <a:bodyPr/>
-          <a:lstStyle/>
-          <a:p>
-            <a:endParaRPr lang="zh-CN" altLang="en-US"/>
-          </a:p>
-        </p:txBody>
       </p:sp>
       <p:sp>
         <p:nvSpPr>
@@ -4518,7 +4621,7 @@
           <a:bodyPr wrap="square" lIns="0" tIns="0" rIns="0" bIns="0" rtlCol="0" anchor="ctr"/>
           <a:lstStyle/>
           <a:p>
-            <a:pPr marL="0" indent="0" algn="l">
+            <a:pPr algn="l" indent="0" marL="0">
               <a:buNone/>
             </a:pPr>
             <a:r>
@@ -4562,13 +4665,6 @@
             <a:prstDash val="solid"/>
           </a:ln>
         </p:spPr>
-        <p:txBody>
-          <a:bodyPr/>
-          <a:lstStyle/>
-          <a:p>
-            <a:endParaRPr lang="zh-CN" altLang="en-US"/>
-          </a:p>
-        </p:txBody>
       </p:sp>
       <p:sp>
         <p:nvSpPr>
@@ -4591,7 +4687,7 @@
           <a:bodyPr wrap="square" lIns="0" tIns="0" rIns="0" bIns="0" rtlCol="0" anchor="ctr"/>
           <a:lstStyle/>
           <a:p>
-            <a:pPr marL="0" indent="0" algn="ctr">
+            <a:pPr algn="ctr" indent="0" marL="0">
               <a:buNone/>
             </a:pPr>
             <a:r>
@@ -4635,13 +4731,6 @@
             <a:prstDash val="solid"/>
           </a:ln>
         </p:spPr>
-        <p:txBody>
-          <a:bodyPr/>
-          <a:lstStyle/>
-          <a:p>
-            <a:endParaRPr lang="zh-CN" altLang="en-US"/>
-          </a:p>
-        </p:txBody>
       </p:sp>
       <p:sp>
         <p:nvSpPr>
@@ -4664,7 +4753,7 @@
           <a:bodyPr wrap="square" lIns="0" tIns="0" rIns="0" bIns="0" rtlCol="0" anchor="ctr"/>
           <a:lstStyle/>
           <a:p>
-            <a:pPr marL="0" indent="0" algn="ctr">
+            <a:pPr algn="ctr" indent="0" marL="0">
               <a:buNone/>
             </a:pPr>
             <a:r>
@@ -4708,13 +4797,6 @@
             <a:prstDash val="solid"/>
           </a:ln>
         </p:spPr>
-        <p:txBody>
-          <a:bodyPr/>
-          <a:lstStyle/>
-          <a:p>
-            <a:endParaRPr lang="zh-CN" altLang="en-US"/>
-          </a:p>
-        </p:txBody>
       </p:sp>
       <p:sp>
         <p:nvSpPr>
@@ -4737,7 +4819,7 @@
           <a:bodyPr wrap="square" lIns="0" tIns="0" rIns="0" bIns="0" rtlCol="0" anchor="ctr"/>
           <a:lstStyle/>
           <a:p>
-            <a:pPr marL="0" indent="0" algn="ctr">
+            <a:pPr algn="ctr" indent="0" marL="0">
               <a:buNone/>
             </a:pPr>
             <a:r>
@@ -4781,13 +4863,6 @@
             <a:prstDash val="solid"/>
           </a:ln>
         </p:spPr>
-        <p:txBody>
-          <a:bodyPr/>
-          <a:lstStyle/>
-          <a:p>
-            <a:endParaRPr lang="zh-CN" altLang="en-US"/>
-          </a:p>
-        </p:txBody>
       </p:sp>
       <p:sp>
         <p:nvSpPr>
@@ -4810,7 +4885,7 @@
           <a:bodyPr wrap="square" lIns="0" tIns="0" rIns="0" bIns="0" rtlCol="0" anchor="ctr"/>
           <a:lstStyle/>
           <a:p>
-            <a:pPr marL="0" indent="0" algn="ctr">
+            <a:pPr algn="ctr" indent="0" marL="0">
               <a:buNone/>
             </a:pPr>
             <a:r>
@@ -4828,16 +4903,148 @@
           </a:p>
         </p:txBody>
       </p:sp>
+      <p:sp>
+        <p:nvSpPr>
+          <p:cNvPr id="19" name="Shape 17"/>
+          <p:cNvSpPr/>
+          <p:nvPr/>
+        </p:nvSpPr>
+        <p:spPr>
+          <a:xfrm>
+            <a:off x="5577840" y="5989320"/>
+            <a:ext cx="1051560" cy="658368"/>
+          </a:xfrm>
+          <a:prstGeom prst="roundRect">
+            <a:avLst>
+              <a:gd name="adj" fmla="val 13889"/>
+            </a:avLst>
+          </a:prstGeom>
+          <a:solidFill>
+            <a:srgbClr val="2B2450"/>
+          </a:solidFill>
+          <a:ln w="12700">
+            <a:solidFill>
+              <a:srgbClr val="3B3460"/>
+            </a:solidFill>
+            <a:prstDash val="solid"/>
+          </a:ln>
+        </p:spPr>
+      </p:sp>
+      <p:sp>
+        <p:nvSpPr>
+          <p:cNvPr id="20" name="Text 18"/>
+          <p:cNvSpPr/>
+          <p:nvPr/>
+        </p:nvSpPr>
+        <p:spPr>
+          <a:xfrm>
+            <a:off x="5577840" y="5989320"/>
+            <a:ext cx="1051560" cy="658368"/>
+          </a:xfrm>
+          <a:prstGeom prst="rect">
+            <a:avLst/>
+          </a:prstGeom>
+          <a:noFill/>
+          <a:ln/>
+        </p:spPr>
+        <p:txBody>
+          <a:bodyPr wrap="square" lIns="0" tIns="0" rIns="0" bIns="0" rtlCol="0" anchor="ctr"/>
+          <a:lstStyle/>
+          <a:p>
+            <a:pPr algn="ctr" indent="0" marL="0">
+              <a:buNone/>
+            </a:pPr>
+            <a:r>
+              <a:rPr lang="en-US" sz="1800" b="1" dirty="0">
+                <a:solidFill>
+                  <a:srgbClr val="EFEDFA"/>
+                </a:solidFill>
+                <a:latin typeface="Segoe UI Semibold" pitchFamily="34" charset="0"/>
+                <a:ea typeface="Segoe UI Semibold" pitchFamily="34" charset="-122"/>
+                <a:cs typeface="Segoe UI Semibold" pitchFamily="34" charset="-120"/>
+              </a:rPr>
+              <a:t>ไทย</a:t>
+            </a:r>
+            <a:endParaRPr lang="en-US" sz="1800" dirty="0"/>
+          </a:p>
+        </p:txBody>
+      </p:sp>
+      <p:sp>
+        <p:nvSpPr>
+          <p:cNvPr id="21" name="Shape 19"/>
+          <p:cNvSpPr/>
+          <p:nvPr/>
+        </p:nvSpPr>
+        <p:spPr>
+          <a:xfrm>
+            <a:off x="6812280" y="5989320"/>
+            <a:ext cx="1051560" cy="658368"/>
+          </a:xfrm>
+          <a:prstGeom prst="roundRect">
+            <a:avLst>
+              <a:gd name="adj" fmla="val 13889"/>
+            </a:avLst>
+          </a:prstGeom>
+          <a:solidFill>
+            <a:srgbClr val="2B2450"/>
+          </a:solidFill>
+          <a:ln w="12700">
+            <a:solidFill>
+              <a:srgbClr val="3B3460"/>
+            </a:solidFill>
+            <a:prstDash val="solid"/>
+          </a:ln>
+        </p:spPr>
+      </p:sp>
+      <p:sp>
+        <p:nvSpPr>
+          <p:cNvPr id="22" name="Text 20"/>
+          <p:cNvSpPr/>
+          <p:nvPr/>
+        </p:nvSpPr>
+        <p:spPr>
+          <a:xfrm>
+            <a:off x="6812280" y="5989320"/>
+            <a:ext cx="1051560" cy="658368"/>
+          </a:xfrm>
+          <a:prstGeom prst="rect">
+            <a:avLst/>
+          </a:prstGeom>
+          <a:noFill/>
+          <a:ln/>
+        </p:spPr>
+        <p:txBody>
+          <a:bodyPr wrap="square" lIns="0" tIns="0" rIns="0" bIns="0" rtlCol="0" anchor="ctr"/>
+          <a:lstStyle/>
+          <a:p>
+            <a:pPr algn="ctr" indent="0" marL="0">
+              <a:buNone/>
+            </a:pPr>
+            <a:r>
+              <a:rPr lang="en-US" sz="1800" b="1" dirty="0">
+                <a:solidFill>
+                  <a:srgbClr val="EFEDFA"/>
+                </a:solidFill>
+                <a:latin typeface="Segoe UI Semibold" pitchFamily="34" charset="0"/>
+                <a:ea typeface="Segoe UI Semibold" pitchFamily="34" charset="-122"/>
+                <a:cs typeface="Segoe UI Semibold" pitchFamily="34" charset="-120"/>
+              </a:rPr>
+              <a:t>हिन्दी</a:t>
+            </a:r>
+            <a:endParaRPr lang="en-US" sz="1800" dirty="0"/>
+          </a:p>
+        </p:txBody>
+      </p:sp>
       <p:pic>
         <p:nvPicPr>
-          <p:cNvPr id="19" name="Image 0" descr="C:\D365DEMO\__Projects\Agent JumpStart 2\promo\img\lab-en.png"/>
+          <p:cNvPr id="23" name="Image 0" descr="C:\D365DEMO\__Projects\Agent JumpStart 2\promo\img\lab-en.png">    </p:cNvPr>
           <p:cNvPicPr>
             <a:picLocks noChangeAspect="1"/>
           </p:cNvPicPr>
           <p:nvPr/>
         </p:nvPicPr>
         <p:blipFill>
-          <a:blip r:embed="rId3"/>
+          <a:blip r:embed="rId1"/>
           <a:stretch>
             <a:fillRect/>
           </a:stretch>
@@ -4854,7 +5061,7 @@
       </p:pic>
       <p:sp>
         <p:nvSpPr>
-          <p:cNvPr id="20" name="Shape 17"/>
+          <p:cNvPr id="24" name="Shape 21"/>
           <p:cNvSpPr/>
           <p:nvPr/>
         </p:nvSpPr>
@@ -4875,24 +5082,17 @@
             <a:prstDash val="solid"/>
           </a:ln>
         </p:spPr>
-        <p:txBody>
-          <a:bodyPr/>
-          <a:lstStyle/>
-          <a:p>
-            <a:endParaRPr lang="zh-CN" altLang="en-US"/>
-          </a:p>
-        </p:txBody>
       </p:sp>
       <p:pic>
         <p:nvPicPr>
-          <p:cNvPr id="21" name="Image 1" descr="C:\D365DEMO\__Projects\Agent JumpStart 2\promo\img\lab-zh.png"/>
+          <p:cNvPr id="25" name="Image 1" descr="C:\D365DEMO\__Projects\Agent JumpStart 2\promo\img\lab-zh.png">    </p:cNvPr>
           <p:cNvPicPr>
             <a:picLocks noChangeAspect="1"/>
           </p:cNvPicPr>
           <p:nvPr/>
         </p:nvPicPr>
         <p:blipFill>
-          <a:blip r:embed="rId4"/>
+          <a:blip r:embed="rId2"/>
           <a:stretch>
             <a:fillRect/>
           </a:stretch>
@@ -4909,7 +5109,7 @@
       </p:pic>
       <p:sp>
         <p:nvSpPr>
-          <p:cNvPr id="22" name="Shape 18"/>
+          <p:cNvPr id="26" name="Shape 22"/>
           <p:cNvSpPr/>
           <p:nvPr/>
         </p:nvSpPr>
@@ -4930,13 +5130,6 @@
             <a:prstDash val="solid"/>
           </a:ln>
         </p:spPr>
-        <p:txBody>
-          <a:bodyPr/>
-          <a:lstStyle/>
-          <a:p>
-            <a:endParaRPr lang="zh-CN" altLang="en-US"/>
-          </a:p>
-        </p:txBody>
       </p:sp>
     </p:spTree>
   </p:cSld>
@@ -4954,7 +5147,6 @@
         <a:solidFill>
           <a:srgbClr val="120F22"/>
         </a:solidFill>
-        <a:effectLst/>
       </p:bgPr>
     </p:bg>
     <p:spTree>
@@ -4992,11 +5184,11 @@
           <a:bodyPr wrap="square" lIns="0" tIns="0" rIns="0" bIns="0" rtlCol="0" anchor="ctr"/>
           <a:lstStyle/>
           <a:p>
-            <a:pPr marL="0" indent="0" algn="l">
-              <a:buNone/>
-            </a:pPr>
-            <a:r>
-              <a:rPr lang="en-US" sz="1250" b="1" kern="0" spc="300" dirty="0">
+            <a:pPr algn="l" indent="0" marL="0">
+              <a:buNone/>
+            </a:pPr>
+            <a:r>
+              <a:rPr lang="en-US" sz="1250" b="1" spc="300" kern="0" dirty="0">
                 <a:solidFill>
                   <a:srgbClr val="A78BFA"/>
                 </a:solidFill>
@@ -5031,7 +5223,7 @@
           <a:bodyPr wrap="square" lIns="0" tIns="0" rIns="0" bIns="0" rtlCol="0" anchor="ctr"/>
           <a:lstStyle/>
           <a:p>
-            <a:pPr marL="0" indent="0" algn="l">
+            <a:pPr algn="l" indent="0" marL="0">
               <a:buNone/>
             </a:pPr>
             <a:r>
@@ -5045,6 +5237,9 @@
               </a:rPr>
               <a:t>A learn-by-doing UX that's </a:t>
             </a:r>
+            <a:pPr algn="l" indent="0" marL="0">
+              <a:buNone/>
+            </a:pPr>
             <a:r>
               <a:rPr lang="en-US" sz="3300" b="1" dirty="0">
                 <a:solidFill>
@@ -5081,13 +5276,6 @@
           </a:solidFill>
           <a:ln/>
         </p:spPr>
-        <p:txBody>
-          <a:bodyPr/>
-          <a:lstStyle/>
-          <a:p>
-            <a:endParaRPr lang="zh-CN" altLang="en-US"/>
-          </a:p>
-        </p:txBody>
       </p:sp>
       <p:sp>
         <p:nvSpPr>
@@ -5110,7 +5298,7 @@
           <a:bodyPr wrap="square" lIns="0" tIns="0" rIns="0" bIns="0" rtlCol="0" anchor="ctr"/>
           <a:lstStyle/>
           <a:p>
-            <a:pPr marL="0" indent="0" algn="ctr">
+            <a:pPr algn="ctr" indent="0" marL="0">
               <a:buNone/>
             </a:pPr>
             <a:r>
@@ -5149,7 +5337,7 @@
           <a:bodyPr wrap="square" lIns="0" tIns="0" rIns="0" bIns="0" rtlCol="0" anchor="ctr"/>
           <a:lstStyle/>
           <a:p>
-            <a:pPr marL="0" indent="0">
+            <a:pPr indent="0" marL="0">
               <a:buNone/>
             </a:pPr>
             <a:r>
@@ -5188,7 +5376,7 @@
           <a:bodyPr wrap="square" lIns="0" tIns="0" rIns="0" bIns="0" rtlCol="0" anchor="ctr"/>
           <a:lstStyle/>
           <a:p>
-            <a:pPr marL="0" indent="0">
+            <a:pPr indent="0" marL="0">
               <a:buNone/>
             </a:pPr>
             <a:r>
@@ -5227,13 +5415,6 @@
           </a:solidFill>
           <a:ln/>
         </p:spPr>
-        <p:txBody>
-          <a:bodyPr/>
-          <a:lstStyle/>
-          <a:p>
-            <a:endParaRPr lang="zh-CN" altLang="en-US"/>
-          </a:p>
-        </p:txBody>
       </p:sp>
       <p:sp>
         <p:nvSpPr>
@@ -5256,7 +5437,7 @@
           <a:bodyPr wrap="square" lIns="0" tIns="0" rIns="0" bIns="0" rtlCol="0" anchor="ctr"/>
           <a:lstStyle/>
           <a:p>
-            <a:pPr marL="0" indent="0" algn="ctr">
+            <a:pPr algn="ctr" indent="0" marL="0">
               <a:buNone/>
             </a:pPr>
             <a:r>
@@ -5295,7 +5476,7 @@
           <a:bodyPr wrap="square" lIns="0" tIns="0" rIns="0" bIns="0" rtlCol="0" anchor="ctr"/>
           <a:lstStyle/>
           <a:p>
-            <a:pPr marL="0" indent="0">
+            <a:pPr indent="0" marL="0">
               <a:buNone/>
             </a:pPr>
             <a:r>
@@ -5334,7 +5515,7 @@
           <a:bodyPr wrap="square" lIns="0" tIns="0" rIns="0" bIns="0" rtlCol="0" anchor="ctr"/>
           <a:lstStyle/>
           <a:p>
-            <a:pPr marL="0" indent="0">
+            <a:pPr indent="0" marL="0">
               <a:buNone/>
             </a:pPr>
             <a:r>
@@ -5373,13 +5554,6 @@
           </a:solidFill>
           <a:ln/>
         </p:spPr>
-        <p:txBody>
-          <a:bodyPr/>
-          <a:lstStyle/>
-          <a:p>
-            <a:endParaRPr lang="zh-CN" altLang="en-US"/>
-          </a:p>
-        </p:txBody>
       </p:sp>
       <p:sp>
         <p:nvSpPr>
@@ -5402,7 +5576,7 @@
           <a:bodyPr wrap="square" lIns="0" tIns="0" rIns="0" bIns="0" rtlCol="0" anchor="ctr"/>
           <a:lstStyle/>
           <a:p>
-            <a:pPr marL="0" indent="0" algn="ctr">
+            <a:pPr algn="ctr" indent="0" marL="0">
               <a:buNone/>
             </a:pPr>
             <a:r>
@@ -5441,7 +5615,7 @@
           <a:bodyPr wrap="square" lIns="0" tIns="0" rIns="0" bIns="0" rtlCol="0" anchor="ctr"/>
           <a:lstStyle/>
           <a:p>
-            <a:pPr marL="0" indent="0">
+            <a:pPr indent="0" marL="0">
               <a:buNone/>
             </a:pPr>
             <a:r>
@@ -5480,7 +5654,7 @@
           <a:bodyPr wrap="square" lIns="0" tIns="0" rIns="0" bIns="0" rtlCol="0" anchor="ctr"/>
           <a:lstStyle/>
           <a:p>
-            <a:pPr marL="0" indent="0">
+            <a:pPr indent="0" marL="0">
               <a:buNone/>
             </a:pPr>
             <a:r>
@@ -5519,13 +5693,6 @@
           </a:solidFill>
           <a:ln/>
         </p:spPr>
-        <p:txBody>
-          <a:bodyPr/>
-          <a:lstStyle/>
-          <a:p>
-            <a:endParaRPr lang="zh-CN" altLang="en-US"/>
-          </a:p>
-        </p:txBody>
       </p:sp>
       <p:sp>
         <p:nvSpPr>
@@ -5548,7 +5715,7 @@
           <a:bodyPr wrap="square" lIns="0" tIns="0" rIns="0" bIns="0" rtlCol="0" anchor="ctr"/>
           <a:lstStyle/>
           <a:p>
-            <a:pPr marL="0" indent="0" algn="ctr">
+            <a:pPr algn="ctr" indent="0" marL="0">
               <a:buNone/>
             </a:pPr>
             <a:r>
@@ -5587,7 +5754,7 @@
           <a:bodyPr wrap="square" lIns="0" tIns="0" rIns="0" bIns="0" rtlCol="0" anchor="ctr"/>
           <a:lstStyle/>
           <a:p>
-            <a:pPr marL="0" indent="0">
+            <a:pPr indent="0" marL="0">
               <a:buNone/>
             </a:pPr>
             <a:r>
@@ -5626,7 +5793,7 @@
           <a:bodyPr wrap="square" lIns="0" tIns="0" rIns="0" bIns="0" rtlCol="0" anchor="ctr"/>
           <a:lstStyle/>
           <a:p>
-            <a:pPr marL="0" indent="0">
+            <a:pPr indent="0" marL="0">
               <a:buNone/>
             </a:pPr>
             <a:r>
@@ -5665,13 +5832,6 @@
           </a:solidFill>
           <a:ln/>
         </p:spPr>
-        <p:txBody>
-          <a:bodyPr/>
-          <a:lstStyle/>
-          <a:p>
-            <a:endParaRPr lang="zh-CN" altLang="en-US"/>
-          </a:p>
-        </p:txBody>
       </p:sp>
       <p:sp>
         <p:nvSpPr>
@@ -5694,7 +5854,7 @@
           <a:bodyPr wrap="square" lIns="0" tIns="0" rIns="0" bIns="0" rtlCol="0" anchor="ctr"/>
           <a:lstStyle/>
           <a:p>
-            <a:pPr marL="0" indent="0" algn="ctr">
+            <a:pPr algn="ctr" indent="0" marL="0">
               <a:buNone/>
             </a:pPr>
             <a:r>
@@ -5733,7 +5893,7 @@
           <a:bodyPr wrap="square" lIns="0" tIns="0" rIns="0" bIns="0" rtlCol="0" anchor="ctr"/>
           <a:lstStyle/>
           <a:p>
-            <a:pPr marL="0" indent="0">
+            <a:pPr indent="0" marL="0">
               <a:buNone/>
             </a:pPr>
             <a:r>
@@ -5772,7 +5932,7 @@
           <a:bodyPr wrap="square" lIns="0" tIns="0" rIns="0" bIns="0" rtlCol="0" anchor="ctr"/>
           <a:lstStyle/>
           <a:p>
-            <a:pPr marL="0" indent="0">
+            <a:pPr indent="0" marL="0">
               <a:buNone/>
             </a:pPr>
             <a:r>
@@ -5792,14 +5952,14 @@
       </p:sp>
       <p:pic>
         <p:nvPicPr>
-          <p:cNvPr id="24" name="Image 0" descr="C:\D365DEMO\__Projects\Agent JumpStart 2\promo\img\lab-overview.png"/>
+          <p:cNvPr id="24" name="Image 0" descr="C:\D365DEMO\__Projects\Agent JumpStart 2\promo\img\lab-overview.png">    </p:cNvPr>
           <p:cNvPicPr>
             <a:picLocks noChangeAspect="1"/>
           </p:cNvPicPr>
           <p:nvPr/>
         </p:nvPicPr>
         <p:blipFill>
-          <a:blip r:embed="rId3"/>
+          <a:blip r:embed="rId1"/>
           <a:stretch>
             <a:fillRect/>
           </a:stretch>
@@ -5837,13 +5997,6 @@
             <a:prstDash val="solid"/>
           </a:ln>
         </p:spPr>
-        <p:txBody>
-          <a:bodyPr/>
-          <a:lstStyle/>
-          <a:p>
-            <a:endParaRPr lang="zh-CN" altLang="en-US"/>
-          </a:p>
-        </p:txBody>
       </p:sp>
     </p:spTree>
   </p:cSld>
@@ -5861,7 +6014,6 @@
         <a:solidFill>
           <a:srgbClr val="181334"/>
         </a:solidFill>
-        <a:effectLst/>
       </p:bgPr>
     </p:bg>
     <p:spTree>
@@ -5899,11 +6051,11 @@
           <a:bodyPr wrap="square" lIns="0" tIns="0" rIns="0" bIns="0" rtlCol="0" anchor="ctr"/>
           <a:lstStyle/>
           <a:p>
-            <a:pPr marL="0" indent="0" algn="l">
-              <a:buNone/>
-            </a:pPr>
-            <a:r>
-              <a:rPr lang="en-US" sz="1250" b="1" kern="0" spc="300" dirty="0">
+            <a:pPr algn="l" indent="0" marL="0">
+              <a:buNone/>
+            </a:pPr>
+            <a:r>
+              <a:rPr lang="en-US" sz="1250" b="1" spc="300" kern="0" dirty="0">
                 <a:solidFill>
                   <a:srgbClr val="A78BFA"/>
                 </a:solidFill>
@@ -5938,7 +6090,7 @@
           <a:bodyPr wrap="square" lIns="0" tIns="0" rIns="0" bIns="0" rtlCol="0" anchor="ctr"/>
           <a:lstStyle/>
           <a:p>
-            <a:pPr marL="0" indent="0" algn="l">
+            <a:pPr algn="l" indent="0" marL="0">
               <a:buNone/>
             </a:pPr>
             <a:r>
@@ -5952,6 +6104,9 @@
               </a:rPr>
               <a:t>Co-brand a </a:t>
             </a:r>
+            <a:pPr algn="l" indent="0" marL="0">
+              <a:buNone/>
+            </a:pPr>
             <a:r>
               <a:rPr lang="en-US" sz="3300" b="1" dirty="0">
                 <a:solidFill>
@@ -5963,6 +6118,9 @@
               </a:rPr>
               <a:t>dedicated workshop</a:t>
             </a:r>
+            <a:pPr algn="l" indent="0" marL="0">
+              <a:buNone/>
+            </a:pPr>
             <a:r>
               <a:rPr lang="en-US" sz="3300" b="1" dirty="0">
                 <a:solidFill>
@@ -5980,14 +6138,14 @@
       </p:sp>
       <p:pic>
         <p:nvPicPr>
-          <p:cNvPr id="4" name="Image 0" descr="C:\D365DEMO\__Projects\Agent JumpStart 2\promo\img\cover-lenovo.png"/>
+          <p:cNvPr id="4" name="Image 0" descr="C:\D365DEMO\__Projects\Agent JumpStart 2\promo\img\cover-lenovo.png">    </p:cNvPr>
           <p:cNvPicPr>
             <a:picLocks noChangeAspect="1"/>
           </p:cNvPicPr>
           <p:nvPr/>
         </p:nvPicPr>
         <p:blipFill>
-          <a:blip r:embed="rId3"/>
+          <a:blip r:embed="rId1"/>
           <a:stretch>
             <a:fillRect/>
           </a:stretch>
@@ -6025,13 +6183,6 @@
             <a:prstDash val="solid"/>
           </a:ln>
         </p:spPr>
-        <p:txBody>
-          <a:bodyPr/>
-          <a:lstStyle/>
-          <a:p>
-            <a:endParaRPr lang="zh-CN" altLang="en-US"/>
-          </a:p>
-        </p:txBody>
       </p:sp>
       <p:sp>
         <p:nvSpPr>
@@ -6054,13 +6205,6 @@
           </a:solidFill>
           <a:ln/>
         </p:spPr>
-        <p:txBody>
-          <a:bodyPr/>
-          <a:lstStyle/>
-          <a:p>
-            <a:endParaRPr lang="zh-CN" altLang="en-US"/>
-          </a:p>
-        </p:txBody>
       </p:sp>
       <p:sp>
         <p:nvSpPr>
@@ -6083,7 +6227,7 @@
           <a:bodyPr wrap="square" lIns="0" tIns="0" rIns="0" bIns="0" rtlCol="0" anchor="ctr"/>
           <a:lstStyle/>
           <a:p>
-            <a:pPr marL="0" indent="0" algn="ctr">
+            <a:pPr algn="ctr" indent="0" marL="0">
               <a:buNone/>
             </a:pPr>
             <a:r>
@@ -6122,7 +6266,7 @@
           <a:bodyPr wrap="square" lIns="0" tIns="0" rIns="0" bIns="0" rtlCol="0" anchor="ctr"/>
           <a:lstStyle/>
           <a:p>
-            <a:pPr marL="0" indent="0">
+            <a:pPr indent="0" marL="0">
               <a:buNone/>
             </a:pPr>
             <a:r>
@@ -6161,7 +6305,7 @@
           <a:bodyPr wrap="square" lIns="0" tIns="0" rIns="0" bIns="0" rtlCol="0" anchor="ctr"/>
           <a:lstStyle/>
           <a:p>
-            <a:pPr marL="0" indent="0">
+            <a:pPr indent="0" marL="0">
               <a:lnSpc>
                 <a:spcPct val="104000"/>
               </a:lnSpc>
@@ -6203,13 +6347,6 @@
           </a:solidFill>
           <a:ln/>
         </p:spPr>
-        <p:txBody>
-          <a:bodyPr/>
-          <a:lstStyle/>
-          <a:p>
-            <a:endParaRPr lang="zh-CN" altLang="en-US"/>
-          </a:p>
-        </p:txBody>
       </p:sp>
       <p:sp>
         <p:nvSpPr>
@@ -6232,7 +6369,7 @@
           <a:bodyPr wrap="square" lIns="0" tIns="0" rIns="0" bIns="0" rtlCol="0" anchor="ctr"/>
           <a:lstStyle/>
           <a:p>
-            <a:pPr marL="0" indent="0" algn="ctr">
+            <a:pPr algn="ctr" indent="0" marL="0">
               <a:buNone/>
             </a:pPr>
             <a:r>
@@ -6271,7 +6408,7 @@
           <a:bodyPr wrap="square" lIns="0" tIns="0" rIns="0" bIns="0" rtlCol="0" anchor="ctr"/>
           <a:lstStyle/>
           <a:p>
-            <a:pPr marL="0" indent="0">
+            <a:pPr indent="0" marL="0">
               <a:buNone/>
             </a:pPr>
             <a:r>
@@ -6310,7 +6447,7 @@
           <a:bodyPr wrap="square" lIns="0" tIns="0" rIns="0" bIns="0" rtlCol="0" anchor="ctr"/>
           <a:lstStyle/>
           <a:p>
-            <a:pPr marL="0" indent="0">
+            <a:pPr indent="0" marL="0">
               <a:lnSpc>
                 <a:spcPct val="104000"/>
               </a:lnSpc>
@@ -6352,13 +6489,6 @@
           </a:solidFill>
           <a:ln/>
         </p:spPr>
-        <p:txBody>
-          <a:bodyPr/>
-          <a:lstStyle/>
-          <a:p>
-            <a:endParaRPr lang="zh-CN" altLang="en-US"/>
-          </a:p>
-        </p:txBody>
       </p:sp>
       <p:sp>
         <p:nvSpPr>
@@ -6381,7 +6511,7 @@
           <a:bodyPr wrap="square" lIns="0" tIns="0" rIns="0" bIns="0" rtlCol="0" anchor="ctr"/>
           <a:lstStyle/>
           <a:p>
-            <a:pPr marL="0" indent="0" algn="ctr">
+            <a:pPr algn="ctr" indent="0" marL="0">
               <a:buNone/>
             </a:pPr>
             <a:r>
@@ -6420,7 +6550,7 @@
           <a:bodyPr wrap="square" lIns="0" tIns="0" rIns="0" bIns="0" rtlCol="0" anchor="ctr"/>
           <a:lstStyle/>
           <a:p>
-            <a:pPr marL="0" indent="0">
+            <a:pPr indent="0" marL="0">
               <a:buNone/>
             </a:pPr>
             <a:r>
@@ -6459,7 +6589,7 @@
           <a:bodyPr wrap="square" lIns="0" tIns="0" rIns="0" bIns="0" rtlCol="0" anchor="ctr"/>
           <a:lstStyle/>
           <a:p>
-            <a:pPr marL="0" indent="0">
+            <a:pPr indent="0" marL="0">
               <a:lnSpc>
                 <a:spcPct val="104000"/>
               </a:lnSpc>
@@ -6501,13 +6631,6 @@
           </a:solidFill>
           <a:ln/>
         </p:spPr>
-        <p:txBody>
-          <a:bodyPr/>
-          <a:lstStyle/>
-          <a:p>
-            <a:endParaRPr lang="zh-CN" altLang="en-US"/>
-          </a:p>
-        </p:txBody>
       </p:sp>
       <p:sp>
         <p:nvSpPr>
@@ -6530,7 +6653,7 @@
           <a:bodyPr wrap="square" lIns="0" tIns="0" rIns="0" bIns="0" rtlCol="0" anchor="ctr"/>
           <a:lstStyle/>
           <a:p>
-            <a:pPr marL="0" indent="0" algn="ctr">
+            <a:pPr algn="ctr" indent="0" marL="0">
               <a:buNone/>
             </a:pPr>
             <a:r>
@@ -6569,7 +6692,7 @@
           <a:bodyPr wrap="square" lIns="0" tIns="0" rIns="0" bIns="0" rtlCol="0" anchor="ctr"/>
           <a:lstStyle/>
           <a:p>
-            <a:pPr marL="0" indent="0">
+            <a:pPr indent="0" marL="0">
               <a:buNone/>
             </a:pPr>
             <a:r>
@@ -6608,7 +6731,7 @@
           <a:bodyPr wrap="square" lIns="0" tIns="0" rIns="0" bIns="0" rtlCol="0" anchor="ctr"/>
           <a:lstStyle/>
           <a:p>
-            <a:pPr marL="0" indent="0">
+            <a:pPr indent="0" marL="0">
               <a:lnSpc>
                 <a:spcPct val="104000"/>
               </a:lnSpc>
@@ -6645,7 +6768,6 @@
         <a:solidFill>
           <a:srgbClr val="120F22"/>
         </a:solidFill>
-        <a:effectLst/>
       </p:bgPr>
     </p:bg>
     <p:spTree>
@@ -6683,11 +6805,11 @@
           <a:bodyPr wrap="square" lIns="0" tIns="0" rIns="0" bIns="0" rtlCol="0" anchor="ctr"/>
           <a:lstStyle/>
           <a:p>
-            <a:pPr marL="0" indent="0" algn="l">
-              <a:buNone/>
-            </a:pPr>
-            <a:r>
-              <a:rPr lang="en-US" sz="1250" b="1" kern="0" spc="300" dirty="0">
+            <a:pPr algn="l" indent="0" marL="0">
+              <a:buNone/>
+            </a:pPr>
+            <a:r>
+              <a:rPr lang="en-US" sz="1250" b="1" spc="300" kern="0" dirty="0">
                 <a:solidFill>
                   <a:srgbClr val="A78BFA"/>
                 </a:solidFill>
@@ -6722,7 +6844,7 @@
           <a:bodyPr wrap="square" lIns="0" tIns="0" rIns="0" bIns="0" rtlCol="0" anchor="ctr"/>
           <a:lstStyle/>
           <a:p>
-            <a:pPr marL="0" indent="0" algn="l">
+            <a:pPr algn="l" indent="0" marL="0">
               <a:buNone/>
             </a:pPr>
             <a:r>
@@ -6736,6 +6858,9 @@
               </a:rPr>
               <a:t>Publish once — </a:t>
             </a:r>
+            <a:pPr algn="l" indent="0" marL="0">
+              <a:buNone/>
+            </a:pPr>
             <a:r>
               <a:rPr lang="en-US" sz="3300" b="1" dirty="0">
                 <a:solidFill>
@@ -6777,13 +6902,6 @@
             <a:prstDash val="solid"/>
           </a:ln>
         </p:spPr>
-        <p:txBody>
-          <a:bodyPr/>
-          <a:lstStyle/>
-          <a:p>
-            <a:endParaRPr lang="zh-CN" altLang="en-US"/>
-          </a:p>
-        </p:txBody>
       </p:sp>
       <p:sp>
         <p:nvSpPr>
@@ -6806,13 +6924,6 @@
           </a:solidFill>
           <a:ln/>
         </p:spPr>
-        <p:txBody>
-          <a:bodyPr/>
-          <a:lstStyle/>
-          <a:p>
-            <a:endParaRPr lang="zh-CN" altLang="en-US"/>
-          </a:p>
-        </p:txBody>
       </p:sp>
       <p:sp>
         <p:nvSpPr>
@@ -6835,7 +6946,7 @@
           <a:bodyPr wrap="square" lIns="0" tIns="0" rIns="0" bIns="0" rtlCol="0" anchor="ctr"/>
           <a:lstStyle/>
           <a:p>
-            <a:pPr marL="0" indent="0" algn="ctr">
+            <a:pPr algn="ctr" indent="0" marL="0">
               <a:buNone/>
             </a:pPr>
             <a:r>
@@ -6874,7 +6985,7 @@
           <a:bodyPr wrap="square" lIns="0" tIns="0" rIns="0" bIns="0" rtlCol="0" anchor="ctr"/>
           <a:lstStyle/>
           <a:p>
-            <a:pPr marL="0" indent="0">
+            <a:pPr indent="0" marL="0">
               <a:buNone/>
             </a:pPr>
             <a:r>
@@ -6913,7 +7024,7 @@
           <a:bodyPr wrap="square" lIns="0" tIns="0" rIns="0" bIns="0" rtlCol="0" anchor="ctr"/>
           <a:lstStyle/>
           <a:p>
-            <a:pPr marL="0" indent="0">
+            <a:pPr indent="0" marL="0">
               <a:lnSpc>
                 <a:spcPct val="108000"/>
               </a:lnSpc>
@@ -6955,7 +7066,7 @@
           <a:bodyPr wrap="square" lIns="0" tIns="0" rIns="0" bIns="0" rtlCol="0" anchor="ctr"/>
           <a:lstStyle/>
           <a:p>
-            <a:pPr marL="0" indent="0" algn="ctr">
+            <a:pPr algn="ctr" indent="0" marL="0">
               <a:buNone/>
             </a:pPr>
             <a:r>
@@ -6999,13 +7110,6 @@
             <a:prstDash val="solid"/>
           </a:ln>
         </p:spPr>
-        <p:txBody>
-          <a:bodyPr/>
-          <a:lstStyle/>
-          <a:p>
-            <a:endParaRPr lang="zh-CN" altLang="en-US"/>
-          </a:p>
-        </p:txBody>
       </p:sp>
       <p:sp>
         <p:nvSpPr>
@@ -7028,13 +7132,6 @@
           </a:solidFill>
           <a:ln/>
         </p:spPr>
-        <p:txBody>
-          <a:bodyPr/>
-          <a:lstStyle/>
-          <a:p>
-            <a:endParaRPr lang="zh-CN" altLang="en-US"/>
-          </a:p>
-        </p:txBody>
       </p:sp>
       <p:sp>
         <p:nvSpPr>
@@ -7057,7 +7154,7 @@
           <a:bodyPr wrap="square" lIns="0" tIns="0" rIns="0" bIns="0" rtlCol="0" anchor="ctr"/>
           <a:lstStyle/>
           <a:p>
-            <a:pPr marL="0" indent="0" algn="ctr">
+            <a:pPr algn="ctr" indent="0" marL="0">
               <a:buNone/>
             </a:pPr>
             <a:r>
@@ -7096,7 +7193,7 @@
           <a:bodyPr wrap="square" lIns="0" tIns="0" rIns="0" bIns="0" rtlCol="0" anchor="ctr"/>
           <a:lstStyle/>
           <a:p>
-            <a:pPr marL="0" indent="0">
+            <a:pPr indent="0" marL="0">
               <a:buNone/>
             </a:pPr>
             <a:r>
@@ -7135,7 +7232,7 @@
           <a:bodyPr wrap="square" lIns="0" tIns="0" rIns="0" bIns="0" rtlCol="0" anchor="ctr"/>
           <a:lstStyle/>
           <a:p>
-            <a:pPr marL="0" indent="0">
+            <a:pPr indent="0" marL="0">
               <a:lnSpc>
                 <a:spcPct val="108000"/>
               </a:lnSpc>
@@ -7177,7 +7274,7 @@
           <a:bodyPr wrap="square" lIns="0" tIns="0" rIns="0" bIns="0" rtlCol="0" anchor="ctr"/>
           <a:lstStyle/>
           <a:p>
-            <a:pPr marL="0" indent="0" algn="ctr">
+            <a:pPr algn="ctr" indent="0" marL="0">
               <a:buNone/>
             </a:pPr>
             <a:r>
@@ -7221,13 +7318,6 @@
             <a:prstDash val="solid"/>
           </a:ln>
         </p:spPr>
-        <p:txBody>
-          <a:bodyPr/>
-          <a:lstStyle/>
-          <a:p>
-            <a:endParaRPr lang="zh-CN" altLang="en-US"/>
-          </a:p>
-        </p:txBody>
       </p:sp>
       <p:sp>
         <p:nvSpPr>
@@ -7250,13 +7340,6 @@
           </a:solidFill>
           <a:ln/>
         </p:spPr>
-        <p:txBody>
-          <a:bodyPr/>
-          <a:lstStyle/>
-          <a:p>
-            <a:endParaRPr lang="zh-CN" altLang="en-US"/>
-          </a:p>
-        </p:txBody>
       </p:sp>
       <p:sp>
         <p:nvSpPr>
@@ -7279,7 +7362,7 @@
           <a:bodyPr wrap="square" lIns="0" tIns="0" rIns="0" bIns="0" rtlCol="0" anchor="ctr"/>
           <a:lstStyle/>
           <a:p>
-            <a:pPr marL="0" indent="0" algn="ctr">
+            <a:pPr algn="ctr" indent="0" marL="0">
               <a:buNone/>
             </a:pPr>
             <a:r>
@@ -7318,7 +7401,7 @@
           <a:bodyPr wrap="square" lIns="0" tIns="0" rIns="0" bIns="0" rtlCol="0" anchor="ctr"/>
           <a:lstStyle/>
           <a:p>
-            <a:pPr marL="0" indent="0">
+            <a:pPr indent="0" marL="0">
               <a:buNone/>
             </a:pPr>
             <a:r>
@@ -7357,7 +7440,7 @@
           <a:bodyPr wrap="square" lIns="0" tIns="0" rIns="0" bIns="0" rtlCol="0" anchor="ctr"/>
           <a:lstStyle/>
           <a:p>
-            <a:pPr marL="0" indent="0">
+            <a:pPr indent="0" marL="0">
               <a:lnSpc>
                 <a:spcPct val="108000"/>
               </a:lnSpc>
@@ -7399,7 +7482,7 @@
           <a:bodyPr wrap="square" lIns="0" tIns="0" rIns="0" bIns="0" rtlCol="0" anchor="ctr"/>
           <a:lstStyle/>
           <a:p>
-            <a:pPr marL="0" indent="0" algn="ctr">
+            <a:pPr algn="ctr" indent="0" marL="0">
               <a:buNone/>
             </a:pPr>
             <a:r>
@@ -7443,13 +7526,6 @@
             <a:prstDash val="solid"/>
           </a:ln>
         </p:spPr>
-        <p:txBody>
-          <a:bodyPr/>
-          <a:lstStyle/>
-          <a:p>
-            <a:endParaRPr lang="zh-CN" altLang="en-US"/>
-          </a:p>
-        </p:txBody>
       </p:sp>
       <p:sp>
         <p:nvSpPr>
@@ -7472,13 +7548,6 @@
           </a:solidFill>
           <a:ln/>
         </p:spPr>
-        <p:txBody>
-          <a:bodyPr/>
-          <a:lstStyle/>
-          <a:p>
-            <a:endParaRPr lang="zh-CN" altLang="en-US"/>
-          </a:p>
-        </p:txBody>
       </p:sp>
       <p:sp>
         <p:nvSpPr>
@@ -7501,7 +7570,7 @@
           <a:bodyPr wrap="square" lIns="0" tIns="0" rIns="0" bIns="0" rtlCol="0" anchor="ctr"/>
           <a:lstStyle/>
           <a:p>
-            <a:pPr marL="0" indent="0" algn="ctr">
+            <a:pPr algn="ctr" indent="0" marL="0">
               <a:buNone/>
             </a:pPr>
             <a:r>
@@ -7540,7 +7609,7 @@
           <a:bodyPr wrap="square" lIns="0" tIns="0" rIns="0" bIns="0" rtlCol="0" anchor="ctr"/>
           <a:lstStyle/>
           <a:p>
-            <a:pPr marL="0" indent="0">
+            <a:pPr indent="0" marL="0">
               <a:buNone/>
             </a:pPr>
             <a:r>
@@ -7579,7 +7648,7 @@
           <a:bodyPr wrap="square" lIns="0" tIns="0" rIns="0" bIns="0" rtlCol="0" anchor="ctr"/>
           <a:lstStyle/>
           <a:p>
-            <a:pPr marL="0" indent="0">
+            <a:pPr indent="0" marL="0">
               <a:lnSpc>
                 <a:spcPct val="108000"/>
               </a:lnSpc>
@@ -7621,7 +7690,7 @@
           <a:bodyPr wrap="square" rtlCol="0" anchor="ctr"/>
           <a:lstStyle/>
           <a:p>
-            <a:pPr marL="0" indent="0" algn="l">
+            <a:pPr algn="l" indent="0" marL="0">
               <a:buNone/>
             </a:pPr>
             <a:r>
@@ -7655,7 +7724,6 @@
         <a:solidFill>
           <a:srgbClr val="181334"/>
         </a:solidFill>
-        <a:effectLst/>
       </p:bgPr>
     </p:bg>
     <p:spTree>
@@ -7693,11 +7761,11 @@
           <a:bodyPr wrap="square" lIns="0" tIns="0" rIns="0" bIns="0" rtlCol="0" anchor="ctr"/>
           <a:lstStyle/>
           <a:p>
-            <a:pPr marL="0" indent="0" algn="l">
-              <a:buNone/>
-            </a:pPr>
-            <a:r>
-              <a:rPr lang="en-US" sz="1250" b="1" kern="0" spc="300" dirty="0">
+            <a:pPr algn="l" indent="0" marL="0">
+              <a:buNone/>
+            </a:pPr>
+            <a:r>
+              <a:rPr lang="en-US" sz="1250" b="1" spc="300" kern="0" dirty="0">
                 <a:solidFill>
                   <a:srgbClr val="A78BFA"/>
                 </a:solidFill>
@@ -7732,7 +7800,7 @@
           <a:bodyPr wrap="square" lIns="0" tIns="0" rIns="0" bIns="0" rtlCol="0" anchor="ctr"/>
           <a:lstStyle/>
           <a:p>
-            <a:pPr marL="0" indent="0" algn="l">
+            <a:pPr algn="l" indent="0" marL="0">
               <a:buNone/>
             </a:pPr>
             <a:r>
@@ -7746,6 +7814,9 @@
               </a:rPr>
               <a:t>Running it is </a:t>
             </a:r>
+            <a:pPr algn="l" indent="0" marL="0">
+              <a:buNone/>
+            </a:pPr>
             <a:r>
               <a:rPr lang="en-US" sz="3300" b="1" dirty="0">
                 <a:solidFill>
@@ -7787,13 +7858,6 @@
             <a:prstDash val="solid"/>
           </a:ln>
         </p:spPr>
-        <p:txBody>
-          <a:bodyPr/>
-          <a:lstStyle/>
-          <a:p>
-            <a:endParaRPr lang="zh-CN" altLang="en-US"/>
-          </a:p>
-        </p:txBody>
       </p:sp>
       <p:sp>
         <p:nvSpPr>
@@ -7816,13 +7880,6 @@
           </a:solidFill>
           <a:ln/>
         </p:spPr>
-        <p:txBody>
-          <a:bodyPr/>
-          <a:lstStyle/>
-          <a:p>
-            <a:endParaRPr lang="zh-CN" altLang="en-US"/>
-          </a:p>
-        </p:txBody>
       </p:sp>
       <p:sp>
         <p:nvSpPr>
@@ -7845,7 +7902,7 @@
           <a:bodyPr wrap="square" lIns="0" tIns="0" rIns="0" bIns="0" rtlCol="0" anchor="ctr"/>
           <a:lstStyle/>
           <a:p>
-            <a:pPr marL="0" indent="0" algn="ctr">
+            <a:pPr algn="ctr" indent="0" marL="0">
               <a:buNone/>
             </a:pPr>
             <a:r>
@@ -7884,7 +7941,7 @@
           <a:bodyPr wrap="square" lIns="0" tIns="0" rIns="0" bIns="0" rtlCol="0" anchor="ctr"/>
           <a:lstStyle/>
           <a:p>
-            <a:pPr marL="0" indent="0">
+            <a:pPr indent="0" marL="0">
               <a:buNone/>
             </a:pPr>
             <a:r>
@@ -7923,7 +7980,7 @@
           <a:bodyPr wrap="square" lIns="0" tIns="0" rIns="0" bIns="0" rtlCol="0" anchor="ctr"/>
           <a:lstStyle/>
           <a:p>
-            <a:pPr marL="0" indent="0">
+            <a:pPr indent="0" marL="0">
               <a:lnSpc>
                 <a:spcPct val="108000"/>
               </a:lnSpc>
@@ -7970,13 +8027,6 @@
             <a:prstDash val="solid"/>
           </a:ln>
         </p:spPr>
-        <p:txBody>
-          <a:bodyPr/>
-          <a:lstStyle/>
-          <a:p>
-            <a:endParaRPr lang="zh-CN" altLang="en-US"/>
-          </a:p>
-        </p:txBody>
       </p:sp>
       <p:sp>
         <p:nvSpPr>
@@ -7999,13 +8049,6 @@
           </a:solidFill>
           <a:ln/>
         </p:spPr>
-        <p:txBody>
-          <a:bodyPr/>
-          <a:lstStyle/>
-          <a:p>
-            <a:endParaRPr lang="zh-CN" altLang="en-US"/>
-          </a:p>
-        </p:txBody>
       </p:sp>
       <p:sp>
         <p:nvSpPr>
@@ -8028,7 +8071,7 @@
           <a:bodyPr wrap="square" lIns="0" tIns="0" rIns="0" bIns="0" rtlCol="0" anchor="ctr"/>
           <a:lstStyle/>
           <a:p>
-            <a:pPr marL="0" indent="0" algn="ctr">
+            <a:pPr algn="ctr" indent="0" marL="0">
               <a:buNone/>
             </a:pPr>
             <a:r>
@@ -8067,7 +8110,7 @@
           <a:bodyPr wrap="square" lIns="0" tIns="0" rIns="0" bIns="0" rtlCol="0" anchor="ctr"/>
           <a:lstStyle/>
           <a:p>
-            <a:pPr marL="0" indent="0">
+            <a:pPr indent="0" marL="0">
               <a:buNone/>
             </a:pPr>
             <a:r>
@@ -8106,7 +8149,7 @@
           <a:bodyPr wrap="square" lIns="0" tIns="0" rIns="0" bIns="0" rtlCol="0" anchor="ctr"/>
           <a:lstStyle/>
           <a:p>
-            <a:pPr marL="0" indent="0">
+            <a:pPr indent="0" marL="0">
               <a:lnSpc>
                 <a:spcPct val="108000"/>
               </a:lnSpc>
@@ -8121,7 +8164,7 @@
                 <a:ea typeface="Segoe UI" pitchFamily="34" charset="-122"/>
                 <a:cs typeface="Segoe UI" pitchFamily="34" charset="-120"/>
               </a:rPr>
-              <a:t>Switch to EN / 中文 / 日本語 / 한국어 on the cover.</a:t>
+              <a:t>Switch to EN / 中文 / 日本語 / 한국어 / ไทย / हिन्दी on the cover.</a:t>
             </a:r>
             <a:endParaRPr lang="en-US" sz="1500" dirty="0"/>
           </a:p>
@@ -8153,13 +8196,6 @@
             <a:prstDash val="solid"/>
           </a:ln>
         </p:spPr>
-        <p:txBody>
-          <a:bodyPr/>
-          <a:lstStyle/>
-          <a:p>
-            <a:endParaRPr lang="zh-CN" altLang="en-US"/>
-          </a:p>
-        </p:txBody>
       </p:sp>
       <p:sp>
         <p:nvSpPr>
@@ -8182,13 +8218,6 @@
           </a:solidFill>
           <a:ln/>
         </p:spPr>
-        <p:txBody>
-          <a:bodyPr/>
-          <a:lstStyle/>
-          <a:p>
-            <a:endParaRPr lang="zh-CN" altLang="en-US"/>
-          </a:p>
-        </p:txBody>
       </p:sp>
       <p:sp>
         <p:nvSpPr>
@@ -8211,7 +8240,7 @@
           <a:bodyPr wrap="square" lIns="0" tIns="0" rIns="0" bIns="0" rtlCol="0" anchor="ctr"/>
           <a:lstStyle/>
           <a:p>
-            <a:pPr marL="0" indent="0" algn="ctr">
+            <a:pPr algn="ctr" indent="0" marL="0">
               <a:buNone/>
             </a:pPr>
             <a:r>
@@ -8250,7 +8279,7 @@
           <a:bodyPr wrap="square" lIns="0" tIns="0" rIns="0" bIns="0" rtlCol="0" anchor="ctr"/>
           <a:lstStyle/>
           <a:p>
-            <a:pPr marL="0" indent="0">
+            <a:pPr indent="0" marL="0">
               <a:buNone/>
             </a:pPr>
             <a:r>
@@ -8289,7 +8318,7 @@
           <a:bodyPr wrap="square" lIns="0" tIns="0" rIns="0" bIns="0" rtlCol="0" anchor="ctr"/>
           <a:lstStyle/>
           <a:p>
-            <a:pPr marL="0" indent="0">
+            <a:pPr indent="0" marL="0">
               <a:lnSpc>
                 <a:spcPct val="108000"/>
               </a:lnSpc>
@@ -8336,13 +8365,6 @@
             <a:prstDash val="solid"/>
           </a:ln>
         </p:spPr>
-        <p:txBody>
-          <a:bodyPr/>
-          <a:lstStyle/>
-          <a:p>
-            <a:endParaRPr lang="zh-CN" altLang="en-US"/>
-          </a:p>
-        </p:txBody>
       </p:sp>
       <p:sp>
         <p:nvSpPr>
@@ -8365,11 +8387,11 @@
           <a:bodyPr wrap="square" lIns="0" tIns="0" rIns="0" bIns="0" rtlCol="0" anchor="ctr"/>
           <a:lstStyle/>
           <a:p>
-            <a:pPr marL="0" indent="0">
-              <a:buNone/>
-            </a:pPr>
-            <a:r>
-              <a:rPr lang="en-US" sz="1300" b="1" kern="0" spc="200" dirty="0">
+            <a:pPr indent="0" marL="0">
+              <a:buNone/>
+            </a:pPr>
+            <a:r>
+              <a:rPr lang="en-US" sz="1300" b="1" spc="200" kern="0" dirty="0">
                 <a:solidFill>
                   <a:srgbClr val="A78BFA"/>
                 </a:solidFill>
@@ -8404,7 +8426,7 @@
           <a:bodyPr wrap="square" lIns="0" tIns="0" rIns="0" bIns="0" rtlCol="0" anchor="ctr"/>
           <a:lstStyle/>
           <a:p>
-            <a:pPr marL="0" indent="0">
+            <a:pPr indent="0" marL="0">
               <a:buNone/>
             </a:pPr>
             <a:r>
@@ -8438,7 +8460,6 @@
         <a:solidFill>
           <a:srgbClr val="120F22"/>
         </a:solidFill>
-        <a:effectLst/>
       </p:bgPr>
     </p:bg>
     <p:spTree>
@@ -8476,13 +8497,6 @@
           </a:solidFill>
           <a:ln/>
         </p:spPr>
-        <p:txBody>
-          <a:bodyPr/>
-          <a:lstStyle/>
-          <a:p>
-            <a:endParaRPr lang="zh-CN" altLang="en-US"/>
-          </a:p>
-        </p:txBody>
       </p:sp>
       <p:sp>
         <p:nvSpPr>
@@ -8505,13 +8519,6 @@
           </a:solidFill>
           <a:ln/>
         </p:spPr>
-        <p:txBody>
-          <a:bodyPr/>
-          <a:lstStyle/>
-          <a:p>
-            <a:endParaRPr lang="zh-CN" altLang="en-US"/>
-          </a:p>
-        </p:txBody>
       </p:sp>
       <p:sp>
         <p:nvSpPr>
@@ -8534,7 +8541,7 @@
           <a:bodyPr wrap="square" rtlCol="0" anchor="ctr"/>
           <a:lstStyle/>
           <a:p>
-            <a:pPr marL="0" indent="0" algn="l">
+            <a:pPr algn="l" indent="0" marL="0">
               <a:buNone/>
             </a:pPr>
             <a:r>
@@ -8548,6 +8555,9 @@
               </a:rPr>
               <a:t>● </a:t>
             </a:r>
+            <a:pPr algn="l" indent="0" marL="0">
+              <a:buNone/>
+            </a:pPr>
             <a:r>
               <a:rPr lang="en-US" sz="1200" b="1" dirty="0">
                 <a:solidFill>
@@ -8584,7 +8594,7 @@
           <a:bodyPr wrap="square" lIns="0" tIns="0" rIns="0" bIns="0" rtlCol="0" anchor="ctr"/>
           <a:lstStyle/>
           <a:p>
-            <a:pPr marL="0" indent="0" algn="l">
+            <a:pPr algn="l" indent="0" marL="0">
               <a:lnSpc>
                 <a:spcPct val="100000"/>
               </a:lnSpc>
@@ -8604,7 +8614,7 @@
             <a:endParaRPr lang="en-US" sz="4000" dirty="0"/>
           </a:p>
           <a:p>
-            <a:pPr marL="0" indent="0" algn="l">
+            <a:pPr algn="l" indent="0" marL="0">
               <a:lnSpc>
                 <a:spcPct val="100000"/>
               </a:lnSpc>
@@ -8646,7 +8656,7 @@
           <a:bodyPr wrap="square" rtlCol="0" anchor="ctr"/>
           <a:lstStyle/>
           <a:p>
-            <a:pPr marL="0" indent="0" algn="l">
+            <a:pPr algn="l" indent="0" marL="0">
               <a:lnSpc>
                 <a:spcPct val="110000"/>
               </a:lnSpc>
@@ -8693,13 +8703,6 @@
             <a:prstDash val="solid"/>
           </a:ln>
         </p:spPr>
-        <p:txBody>
-          <a:bodyPr/>
-          <a:lstStyle/>
-          <a:p>
-            <a:endParaRPr lang="zh-CN" altLang="en-US"/>
-          </a:p>
-        </p:txBody>
       </p:sp>
       <p:sp>
         <p:nvSpPr>
@@ -8722,7 +8725,7 @@
           <a:bodyPr wrap="square" lIns="0" tIns="0" rIns="0" bIns="0" rtlCol="0" anchor="ctr"/>
           <a:lstStyle/>
           <a:p>
-            <a:pPr marL="0" indent="0">
+            <a:pPr indent="0" marL="0">
               <a:buNone/>
             </a:pPr>
             <a:r>
@@ -8761,7 +8764,7 @@
           <a:bodyPr wrap="square" lIns="0" tIns="0" rIns="0" bIns="0" rtlCol="0" anchor="ctr"/>
           <a:lstStyle/>
           <a:p>
-            <a:pPr marL="0" indent="0">
+            <a:pPr indent="0" marL="0">
               <a:buNone/>
             </a:pPr>
             <a:r>
@@ -8800,7 +8803,7 @@
           <a:bodyPr wrap="square" rtlCol="0" anchor="ctr"/>
           <a:lstStyle/>
           <a:p>
-            <a:pPr marL="0" indent="0" algn="l">
+            <a:pPr algn="l" indent="0" marL="0">
               <a:buNone/>
             </a:pPr>
             <a:r>
@@ -8820,21 +8823,22 @@
       </p:sp>
       <p:pic>
         <p:nvPicPr>
-          <p:cNvPr id="11" name="Image 0"/>
+          <p:cNvPr id="11" name="Image 0" descr="C:\D365DEMO\__Projects\Agent JumpStart 2\promo\img\michael.png">    </p:cNvPr>
           <p:cNvPicPr>
             <a:picLocks noChangeAspect="1"/>
           </p:cNvPicPr>
           <p:nvPr/>
         </p:nvPicPr>
         <p:blipFill>
-          <a:blip r:embed="rId3"/>
-          <a:srcRect/>
-          <a:stretch/>
+          <a:blip r:embed="rId1"/>
+          <a:stretch>
+            <a:fillRect/>
+          </a:stretch>
         </p:blipFill>
         <p:spPr>
           <a:xfrm>
-            <a:off x="8549640" y="1790348"/>
-            <a:ext cx="2834640" cy="2820103"/>
+            <a:off x="8549640" y="1783080"/>
+            <a:ext cx="2834640" cy="2834640"/>
           </a:xfrm>
           <a:prstGeom prst="rect">
             <a:avLst/>
@@ -8862,7 +8866,7 @@
           <a:bodyPr wrap="square" lIns="0" tIns="0" rIns="0" bIns="0" rtlCol="0" anchor="ctr"/>
           <a:lstStyle/>
           <a:p>
-            <a:pPr marL="0" indent="0" algn="ctr">
+            <a:pPr algn="ctr" indent="0" marL="0">
               <a:buNone/>
             </a:pPr>
             <a:r>
@@ -8901,7 +8905,7 @@
           <a:bodyPr wrap="square" lIns="0" tIns="0" rIns="0" bIns="0" rtlCol="0" anchor="ctr"/>
           <a:lstStyle/>
           <a:p>
-            <a:pPr marL="0" indent="0" algn="ctr">
+            <a:pPr algn="ctr" indent="0" marL="0">
               <a:buNone/>
             </a:pPr>
             <a:r>
@@ -9220,325 +9224,4 @@
     </a:ext>
   </a:extLst>
 </a:theme>
-</file>
-
-<file path=ppt/theme/theme2.xml><?xml version="1.0" encoding="utf-8"?>
-<a:theme xmlns:a="http://schemas.openxmlformats.org/drawingml/2006/main" name="Office 主题​​">
-  <a:themeElements>
-    <a:clrScheme name="Office">
-      <a:dk1>
-        <a:sysClr val="windowText" lastClr="000000"/>
-      </a:dk1>
-      <a:lt1>
-        <a:sysClr val="window" lastClr="FFFFFF"/>
-      </a:lt1>
-      <a:dk2>
-        <a:srgbClr val="0E2841"/>
-      </a:dk2>
-      <a:lt2>
-        <a:srgbClr val="E8E8E8"/>
-      </a:lt2>
-      <a:accent1>
-        <a:srgbClr val="156082"/>
-      </a:accent1>
-      <a:accent2>
-        <a:srgbClr val="E97132"/>
-      </a:accent2>
-      <a:accent3>
-        <a:srgbClr val="196B24"/>
-      </a:accent3>
-      <a:accent4>
-        <a:srgbClr val="0F9ED5"/>
-      </a:accent4>
-      <a:accent5>
-        <a:srgbClr val="A02B93"/>
-      </a:accent5>
-      <a:accent6>
-        <a:srgbClr val="4EA72E"/>
-      </a:accent6>
-      <a:hlink>
-        <a:srgbClr val="467886"/>
-      </a:hlink>
-      <a:folHlink>
-        <a:srgbClr val="96607D"/>
-      </a:folHlink>
-    </a:clrScheme>
-    <a:fontScheme name="Office">
-      <a:majorFont>
-        <a:latin typeface="等线 Light" panose="02110004020202020204"/>
-        <a:ea typeface=""/>
-        <a:cs typeface=""/>
-        <a:font script="Jpan" typeface="游ゴシック Light"/>
-        <a:font script="Hang" typeface="맑은 고딕"/>
-        <a:font script="Hans" typeface="等线 Light"/>
-        <a:font script="Hant" typeface="新細明體"/>
-        <a:font script="Arab" typeface="Times New Roman"/>
-        <a:font script="Hebr" typeface="Times New Roman"/>
-        <a:font script="Thai" typeface="Angsana New"/>
-        <a:font script="Ethi" typeface="Nyala"/>
-        <a:font script="Beng" typeface="Vrinda"/>
-        <a:font script="Gujr" typeface="Shruti"/>
-        <a:font script="Khmr" typeface="MoolBoran"/>
-        <a:font script="Knda" typeface="Tunga"/>
-        <a:font script="Guru" typeface="Raavi"/>
-        <a:font script="Cans" typeface="Euphemia"/>
-        <a:font script="Cher" typeface="Plantagenet Cherokee"/>
-        <a:font script="Yiii" typeface="Microsoft Yi Baiti"/>
-        <a:font script="Tibt" typeface="Microsoft Himalaya"/>
-        <a:font script="Thaa" typeface="MV Boli"/>
-        <a:font script="Deva" typeface="Mangal"/>
-        <a:font script="Telu" typeface="Gautami"/>
-        <a:font script="Taml" typeface="Latha"/>
-        <a:font script="Syrc" typeface="Estrangelo Edessa"/>
-        <a:font script="Orya" typeface="Kalinga"/>
-        <a:font script="Mlym" typeface="Kartika"/>
-        <a:font script="Laoo" typeface="DokChampa"/>
-        <a:font script="Sinh" typeface="Iskoola Pota"/>
-        <a:font script="Mong" typeface="Mongolian Baiti"/>
-        <a:font script="Viet" typeface="Times New Roman"/>
-        <a:font script="Uigh" typeface="Microsoft Uighur"/>
-        <a:font script="Geor" typeface="Sylfaen"/>
-        <a:font script="Armn" typeface="Arial"/>
-        <a:font script="Bugi" typeface="Leelawadee UI"/>
-        <a:font script="Bopo" typeface="Microsoft JhengHei"/>
-        <a:font script="Java" typeface="Javanese Text"/>
-        <a:font script="Lisu" typeface="Segoe UI"/>
-        <a:font script="Mymr" typeface="Myanmar Text"/>
-        <a:font script="Nkoo" typeface="Ebrima"/>
-        <a:font script="Olck" typeface="Nirmala UI"/>
-        <a:font script="Osma" typeface="Ebrima"/>
-        <a:font script="Phag" typeface="Phagspa"/>
-        <a:font script="Syrn" typeface="Estrangelo Edessa"/>
-        <a:font script="Syrj" typeface="Estrangelo Edessa"/>
-        <a:font script="Syre" typeface="Estrangelo Edessa"/>
-        <a:font script="Sora" typeface="Nirmala UI"/>
-        <a:font script="Tale" typeface="Microsoft Tai Le"/>
-        <a:font script="Talu" typeface="Microsoft New Tai Lue"/>
-        <a:font script="Tfng" typeface="Ebrima"/>
-      </a:majorFont>
-      <a:minorFont>
-        <a:latin typeface="等线" panose="02110004020202020204"/>
-        <a:ea typeface=""/>
-        <a:cs typeface=""/>
-        <a:font script="Jpan" typeface="游ゴシック"/>
-        <a:font script="Hang" typeface="맑은 고딕"/>
-        <a:font script="Hans" typeface="等线"/>
-        <a:font script="Hant" typeface="新細明體"/>
-        <a:font script="Arab" typeface="Arial"/>
-        <a:font script="Hebr" typeface="Arial"/>
-        <a:font script="Thai" typeface="Cordia New"/>
-        <a:font script="Ethi" typeface="Nyala"/>
-        <a:font script="Beng" typeface="Vrinda"/>
-        <a:font script="Gujr" typeface="Shruti"/>
-        <a:font script="Khmr" typeface="DaunPenh"/>
-        <a:font script="Knda" typeface="Tunga"/>
-        <a:font script="Guru" typeface="Raavi"/>
-        <a:font script="Cans" typeface="Euphemia"/>
-        <a:font script="Cher" typeface="Plantagenet Cherokee"/>
-        <a:font script="Yiii" typeface="Microsoft Yi Baiti"/>
-        <a:font script="Tibt" typeface="Microsoft Himalaya"/>
-        <a:font script="Thaa" typeface="MV Boli"/>
-        <a:font script="Deva" typeface="Mangal"/>
-        <a:font script="Telu" typeface="Gautami"/>
-        <a:font script="Taml" typeface="Latha"/>
-        <a:font script="Syrc" typeface="Estrangelo Edessa"/>
-        <a:font script="Orya" typeface="Kalinga"/>
-        <a:font script="Mlym" typeface="Kartika"/>
-        <a:font script="Laoo" typeface="DokChampa"/>
-        <a:font script="Sinh" typeface="Iskoola Pota"/>
-        <a:font script="Mong" typeface="Mongolian Baiti"/>
-        <a:font script="Viet" typeface="Arial"/>
-        <a:font script="Uigh" typeface="Microsoft Uighur"/>
-        <a:font script="Geor" typeface="Sylfaen"/>
-        <a:font script="Armn" typeface="Arial"/>
-        <a:font script="Bugi" typeface="Leelawadee UI"/>
-        <a:font script="Bopo" typeface="Microsoft JhengHei"/>
-        <a:font script="Java" typeface="Javanese Text"/>
-        <a:font script="Lisu" typeface="Segoe UI"/>
-        <a:font script="Mymr" typeface="Myanmar Text"/>
-        <a:font script="Nkoo" typeface="Ebrima"/>
-        <a:font script="Olck" typeface="Nirmala UI"/>
-        <a:font script="Osma" typeface="Ebrima"/>
-        <a:font script="Phag" typeface="Phagspa"/>
-        <a:font script="Syrn" typeface="Estrangelo Edessa"/>
-        <a:font script="Syrj" typeface="Estrangelo Edessa"/>
-        <a:font script="Syre" typeface="Estrangelo Edessa"/>
-        <a:font script="Sora" typeface="Nirmala UI"/>
-        <a:font script="Tale" typeface="Microsoft Tai Le"/>
-        <a:font script="Talu" typeface="Microsoft New Tai Lue"/>
-        <a:font script="Tfng" typeface="Ebrima"/>
-      </a:minorFont>
-    </a:fontScheme>
-    <a:fmtScheme name="Office">
-      <a:fillStyleLst>
-        <a:solidFill>
-          <a:schemeClr val="phClr"/>
-        </a:solidFill>
-        <a:gradFill rotWithShape="1">
-          <a:gsLst>
-            <a:gs pos="0">
-              <a:schemeClr val="phClr">
-                <a:lumMod val="110000"/>
-                <a:satMod val="105000"/>
-                <a:tint val="67000"/>
-              </a:schemeClr>
-            </a:gs>
-            <a:gs pos="50000">
-              <a:schemeClr val="phClr">
-                <a:lumMod val="105000"/>
-                <a:satMod val="103000"/>
-                <a:tint val="73000"/>
-              </a:schemeClr>
-            </a:gs>
-            <a:gs pos="100000">
-              <a:schemeClr val="phClr">
-                <a:lumMod val="105000"/>
-                <a:satMod val="109000"/>
-                <a:tint val="81000"/>
-              </a:schemeClr>
-            </a:gs>
-          </a:gsLst>
-          <a:lin ang="5400000" scaled="0"/>
-        </a:gradFill>
-        <a:gradFill rotWithShape="1">
-          <a:gsLst>
-            <a:gs pos="0">
-              <a:schemeClr val="phClr">
-                <a:satMod val="103000"/>
-                <a:lumMod val="102000"/>
-                <a:tint val="94000"/>
-              </a:schemeClr>
-            </a:gs>
-            <a:gs pos="50000">
-              <a:schemeClr val="phClr">
-                <a:satMod val="110000"/>
-                <a:lumMod val="100000"/>
-                <a:shade val="100000"/>
-              </a:schemeClr>
-            </a:gs>
-            <a:gs pos="100000">
-              <a:schemeClr val="phClr">
-                <a:lumMod val="99000"/>
-                <a:satMod val="120000"/>
-                <a:shade val="78000"/>
-              </a:schemeClr>
-            </a:gs>
-          </a:gsLst>
-          <a:lin ang="5400000" scaled="0"/>
-        </a:gradFill>
-      </a:fillStyleLst>
-      <a:lnStyleLst>
-        <a:ln w="12700" cap="flat" cmpd="sng" algn="ctr">
-          <a:solidFill>
-            <a:schemeClr val="phClr"/>
-          </a:solidFill>
-          <a:prstDash val="solid"/>
-          <a:miter lim="800000"/>
-        </a:ln>
-        <a:ln w="19050" cap="flat" cmpd="sng" algn="ctr">
-          <a:solidFill>
-            <a:schemeClr val="phClr"/>
-          </a:solidFill>
-          <a:prstDash val="solid"/>
-          <a:miter lim="800000"/>
-        </a:ln>
-        <a:ln w="25400" cap="flat" cmpd="sng" algn="ctr">
-          <a:solidFill>
-            <a:schemeClr val="phClr"/>
-          </a:solidFill>
-          <a:prstDash val="solid"/>
-          <a:miter lim="800000"/>
-        </a:ln>
-      </a:lnStyleLst>
-      <a:effectStyleLst>
-        <a:effectStyle>
-          <a:effectLst/>
-        </a:effectStyle>
-        <a:effectStyle>
-          <a:effectLst/>
-        </a:effectStyle>
-        <a:effectStyle>
-          <a:effectLst>
-            <a:outerShdw blurRad="57150" dist="19050" dir="5400000" algn="ctr" rotWithShape="0">
-              <a:srgbClr val="000000">
-                <a:alpha val="63000"/>
-              </a:srgbClr>
-            </a:outerShdw>
-          </a:effectLst>
-        </a:effectStyle>
-      </a:effectStyleLst>
-      <a:bgFillStyleLst>
-        <a:solidFill>
-          <a:schemeClr val="phClr"/>
-        </a:solidFill>
-        <a:solidFill>
-          <a:schemeClr val="phClr">
-            <a:tint val="95000"/>
-            <a:satMod val="170000"/>
-          </a:schemeClr>
-        </a:solidFill>
-        <a:gradFill rotWithShape="1">
-          <a:gsLst>
-            <a:gs pos="0">
-              <a:schemeClr val="phClr">
-                <a:tint val="93000"/>
-                <a:satMod val="150000"/>
-                <a:shade val="98000"/>
-                <a:lumMod val="102000"/>
-              </a:schemeClr>
-            </a:gs>
-            <a:gs pos="50000">
-              <a:schemeClr val="phClr">
-                <a:tint val="98000"/>
-                <a:satMod val="130000"/>
-                <a:shade val="90000"/>
-                <a:lumMod val="103000"/>
-              </a:schemeClr>
-            </a:gs>
-            <a:gs pos="100000">
-              <a:schemeClr val="phClr">
-                <a:shade val="63000"/>
-                <a:satMod val="120000"/>
-              </a:schemeClr>
-            </a:gs>
-          </a:gsLst>
-          <a:lin ang="5400000" scaled="0"/>
-        </a:gradFill>
-      </a:bgFillStyleLst>
-    </a:fmtScheme>
-  </a:themeElements>
-  <a:objectDefaults>
-    <a:lnDef>
-      <a:spPr/>
-      <a:bodyPr/>
-      <a:lstStyle/>
-      <a:style>
-        <a:lnRef idx="2">
-          <a:schemeClr val="accent1"/>
-        </a:lnRef>
-        <a:fillRef idx="0">
-          <a:schemeClr val="accent1"/>
-        </a:fillRef>
-        <a:effectRef idx="1">
-          <a:schemeClr val="accent1"/>
-        </a:effectRef>
-        <a:fontRef idx="minor">
-          <a:schemeClr val="tx1"/>
-        </a:fontRef>
-      </a:style>
-    </a:lnDef>
-  </a:objectDefaults>
-  <a:extraClrSchemeLst/>
-  <a:extLst>
-    <a:ext uri="{05A4C25C-085E-4340-85A3-A5531E510DB2}">
-      <thm15:themeFamily xmlns:thm15="http://schemas.microsoft.com/office/thememl/2012/main" name="Office Theme" id="{2E142A2C-CD16-42D6-873A-C26D2A0506FA}" vid="{1BDDFF52-6CD6-40A5-AB3C-68EB2F1E4D0A}"/>
-    </a:ext>
-  </a:extLst>
-</a:theme>
-</file>
-
-<file path=docMetadata/LabelInfo.xml><?xml version="1.0" encoding="utf-8"?>
-<clbl:labelList xmlns:clbl="http://schemas.microsoft.com/office/2020/mipLabelMetadata">
-  <clbl:label id="{f42aa342-8706-4288-bd11-ebb85995028c}" enabled="1" method="Standard" siteId="{72f988bf-86f1-41af-91ab-2d7cd011db47}" contentBits="0" removed="0"/>
-</clbl:labelList>
 </file>
</xml_diff>

<commit_message>
PPTX: insert Agent Platform Blueprint as slide 4 (matches HTML deck); generator now emits EN PNG for PowerPoint
</commit_message>
<xml_diff>
--- a/promo/JumpStart-v2-Workshop-Highlights.pptx
+++ b/promo/JumpStart-v2-Workshop-Highlights.pptx
@@ -14,9 +14,10 @@
     <p:sldId id="262" r:id="rId8"/>
     <p:sldId id="263" r:id="rId9"/>
     <p:sldId id="264" r:id="rId10"/>
+    <p:sldId id="265" r:id="rId11"/>
   </p:sldIdLst>
   <p:notesMasterIdLst>
-    <p:notesMasterId r:id="rId11"/>
+    <p:notesMasterId r:id="rId12"/>
   </p:notesMasterIdLst>
   <p:sldSz cx="12191695" cy="6858000"/>
   <p:notesSz cx="6858000" cy="12191695"/>
@@ -534,6 +535,94 @@
             <a:fld id="{F7021451-1387-4CA6-816F-3879F97B5CBC}" type="slidenum">
               <a:rPr lang="en-US"/>
               <a:t>1</a:t>
+            </a:fld>
+            <a:endParaRPr lang="en-US"/>
+          </a:p>
+        </p:txBody>
+      </p:sp>
+    </p:spTree>
+    <p:extLst>
+      <p:ext uri="{BB962C8B-B14F-4D97-AF65-F5344CB8AC3E}">
+        <p14:creationId xmlns:p14="http://schemas.microsoft.com/office/powerpoint/2010/main" val="1024086991"/>
+      </p:ext>
+    </p:extLst>
+  </p:cSld>
+  <p:clrMapOvr>
+    <a:masterClrMapping/>
+  </p:clrMapOvr>
+</p:notes>
+</file>
+
+<file path=ppt/notesSlides/notesSlide10.xml><?xml version="1.0" encoding="utf-8"?>
+<p:notes xmlns:a="http://schemas.openxmlformats.org/drawingml/2006/main" xmlns:r="http://schemas.openxmlformats.org/officeDocument/2006/relationships" xmlns:p="http://schemas.openxmlformats.org/presentationml/2006/main">
+  <p:cSld>
+    <p:spTree>
+      <p:nvGrpSpPr>
+        <p:cNvPr id="1" name=""/>
+        <p:cNvGrpSpPr/>
+        <p:nvPr/>
+      </p:nvGrpSpPr>
+      <p:grpSpPr>
+        <a:xfrm>
+          <a:off x="0" y="0"/>
+          <a:ext cx="0" cy="0"/>
+          <a:chOff x="0" y="0"/>
+          <a:chExt cx="0" cy="0"/>
+        </a:xfrm>
+      </p:grpSpPr>
+      <p:sp>
+        <p:nvSpPr>
+          <p:cNvPr id="2" name="Slide Image Placeholder 1"/>
+          <p:cNvSpPr>
+            <a:spLocks noGrp="1" noRot="1" noChangeAspect="1"/>
+          </p:cNvSpPr>
+          <p:nvPr>
+            <p:ph type="sldImg"/>
+          </p:nvPr>
+        </p:nvSpPr>
+        <p:spPr/>
+      </p:sp>
+      <p:sp>
+        <p:nvSpPr>
+          <p:cNvPr id="3" name="Notes Placeholder 2"/>
+          <p:cNvSpPr>
+            <a:spLocks noGrp="1"/>
+          </p:cNvSpPr>
+          <p:nvPr>
+            <p:ph type="body" idx="1"/>
+          </p:nvPr>
+        </p:nvSpPr>
+        <p:spPr/>
+        <p:txBody>
+          <a:bodyPr/>
+          <a:lstStyle/>
+          <a:p>
+            <a:r>
+              <a:rPr lang="en-US" dirty="0"/>
+              <a:t/>
+            </a:r>
+            <a:endParaRPr lang="en-US" dirty="0"/>
+          </a:p>
+        </p:txBody>
+      </p:sp>
+      <p:sp>
+        <p:nvSpPr>
+          <p:cNvPr id="4" name="Slide Number Placeholder 3"/>
+          <p:cNvSpPr>
+            <a:spLocks noGrp="1"/>
+          </p:cNvSpPr>
+          <p:nvPr>
+            <p:ph type="sldNum" sz="quarter" idx="10"/>
+          </p:nvPr>
+        </p:nvSpPr>
+        <p:spPr/>
+        <p:txBody>
+          <a:bodyPr/>
+          <a:lstStyle/>
+          <a:p>
+            <a:fld id="{F7021451-1387-4CA6-816F-3879F97B5CBC}" type="slidenum">
+              <a:rPr lang="en-US"/>
+              <a:t>10</a:t>
             </a:fld>
             <a:endParaRPr lang="en-US"/>
           </a:p>
@@ -2147,6 +2236,485 @@
 </p:sld>
 </file>
 
+<file path=ppt/slides/slide10.xml><?xml version="1.0" encoding="utf-8"?>
+<p:sld xmlns:a="http://schemas.openxmlformats.org/drawingml/2006/main" xmlns:r="http://schemas.openxmlformats.org/officeDocument/2006/relationships" xmlns:p="http://schemas.openxmlformats.org/presentationml/2006/main">
+  <p:cSld name="Slide 10">
+    <p:bg>
+      <p:bgPr>
+        <a:solidFill>
+          <a:srgbClr val="120F22"/>
+        </a:solidFill>
+      </p:bgPr>
+    </p:bg>
+    <p:spTree>
+      <p:nvGrpSpPr>
+        <p:cNvPr id="1" name=""/>
+        <p:cNvGrpSpPr/>
+        <p:nvPr/>
+      </p:nvGrpSpPr>
+      <p:grpSpPr>
+        <a:xfrm>
+          <a:off x="0" y="0"/>
+          <a:ext cx="0" cy="0"/>
+          <a:chOff x="0" y="0"/>
+          <a:chExt cx="0" cy="0"/>
+        </a:xfrm>
+      </p:grpSpPr>
+      <p:sp>
+        <p:nvSpPr>
+          <p:cNvPr id="2" name="Shape 0"/>
+          <p:cNvSpPr/>
+          <p:nvPr/>
+        </p:nvSpPr>
+        <p:spPr>
+          <a:xfrm>
+            <a:off x="-2194560" y="-2743200"/>
+            <a:ext cx="6858000" cy="6858000"/>
+          </a:xfrm>
+          <a:prstGeom prst="ellipse">
+            <a:avLst/>
+          </a:prstGeom>
+          <a:solidFill>
+            <a:srgbClr val="7C3AED">
+              <a:alpha val="22000"/>
+            </a:srgbClr>
+          </a:solidFill>
+          <a:ln/>
+        </p:spPr>
+      </p:sp>
+      <p:sp>
+        <p:nvSpPr>
+          <p:cNvPr id="3" name="Shape 1"/>
+          <p:cNvSpPr/>
+          <p:nvPr/>
+        </p:nvSpPr>
+        <p:spPr>
+          <a:xfrm>
+            <a:off x="8412480" y="4023360"/>
+            <a:ext cx="6400800" cy="6400800"/>
+          </a:xfrm>
+          <a:prstGeom prst="ellipse">
+            <a:avLst/>
+          </a:prstGeom>
+          <a:solidFill>
+            <a:srgbClr val="EC4899">
+              <a:alpha val="18000"/>
+            </a:srgbClr>
+          </a:solidFill>
+          <a:ln/>
+        </p:spPr>
+      </p:sp>
+      <p:sp>
+        <p:nvSpPr>
+          <p:cNvPr id="4" name="Text 2"/>
+          <p:cNvSpPr/>
+          <p:nvPr/>
+        </p:nvSpPr>
+        <p:spPr>
+          <a:xfrm>
+            <a:off x="640080" y="822960"/>
+            <a:ext cx="4572000" cy="365760"/>
+          </a:xfrm>
+          <a:prstGeom prst="rect">
+            <a:avLst/>
+          </a:prstGeom>
+          <a:noFill/>
+          <a:ln/>
+        </p:spPr>
+        <p:txBody>
+          <a:bodyPr wrap="square" rtlCol="0" anchor="ctr"/>
+          <a:lstStyle/>
+          <a:p>
+            <a:pPr algn="l" indent="0" marL="0">
+              <a:buNone/>
+            </a:pPr>
+            <a:r>
+              <a:rPr lang="en-US" sz="1200" b="1" dirty="0">
+                <a:solidFill>
+                  <a:srgbClr val="F472B6"/>
+                </a:solidFill>
+                <a:latin typeface="Segoe UI" pitchFamily="34" charset="0"/>
+                <a:ea typeface="Segoe UI" pitchFamily="34" charset="-122"/>
+                <a:cs typeface="Segoe UI" pitchFamily="34" charset="-120"/>
+              </a:rPr>
+              <a:t>● </a:t>
+            </a:r>
+            <a:pPr algn="l" indent="0" marL="0">
+              <a:buNone/>
+            </a:pPr>
+            <a:r>
+              <a:rPr lang="en-US" sz="1200" b="1" dirty="0">
+                <a:solidFill>
+                  <a:srgbClr val="E9E6FF"/>
+                </a:solidFill>
+                <a:latin typeface="Segoe UI" pitchFamily="34" charset="0"/>
+                <a:ea typeface="Segoe UI" pitchFamily="34" charset="-122"/>
+                <a:cs typeface="Segoe UI" pitchFamily="34" charset="-120"/>
+              </a:rPr>
+              <a:t>Ready when you are</a:t>
+            </a:r>
+            <a:endParaRPr lang="en-US" sz="1200" dirty="0"/>
+          </a:p>
+        </p:txBody>
+      </p:sp>
+      <p:sp>
+        <p:nvSpPr>
+          <p:cNvPr id="5" name="Text 3"/>
+          <p:cNvSpPr/>
+          <p:nvPr/>
+        </p:nvSpPr>
+        <p:spPr>
+          <a:xfrm>
+            <a:off x="603504" y="1554480"/>
+            <a:ext cx="7589520" cy="1737360"/>
+          </a:xfrm>
+          <a:prstGeom prst="rect">
+            <a:avLst/>
+          </a:prstGeom>
+          <a:noFill/>
+          <a:ln/>
+        </p:spPr>
+        <p:txBody>
+          <a:bodyPr wrap="square" lIns="0" tIns="0" rIns="0" bIns="0" rtlCol="0" anchor="ctr"/>
+          <a:lstStyle/>
+          <a:p>
+            <a:pPr algn="l" indent="0" marL="0">
+              <a:lnSpc>
+                <a:spcPct val="100000"/>
+              </a:lnSpc>
+              <a:buNone/>
+            </a:pPr>
+            <a:r>
+              <a:rPr lang="en-US" sz="4000" b="1" dirty="0">
+                <a:solidFill>
+                  <a:srgbClr val="FFFFFF"/>
+                </a:solidFill>
+                <a:latin typeface="Segoe UI Semibold" pitchFamily="34" charset="0"/>
+                <a:ea typeface="Segoe UI Semibold" pitchFamily="34" charset="-122"/>
+                <a:cs typeface="Segoe UI Semibold" pitchFamily="34" charset="-120"/>
+              </a:rPr>
+              <a:t>Bring JumpStart v2 to your</a:t>
+            </a:r>
+            <a:endParaRPr lang="en-US" sz="4000" dirty="0"/>
+          </a:p>
+          <a:p>
+            <a:pPr algn="l" indent="0" marL="0">
+              <a:lnSpc>
+                <a:spcPct val="100000"/>
+              </a:lnSpc>
+              <a:buNone/>
+            </a:pPr>
+            <a:r>
+              <a:rPr lang="en-US" sz="4000" b="1" dirty="0">
+                <a:solidFill>
+                  <a:srgbClr val="A78BFA"/>
+                </a:solidFill>
+                <a:latin typeface="Segoe UI Semibold" pitchFamily="34" charset="0"/>
+                <a:ea typeface="Segoe UI Semibold" pitchFamily="34" charset="-122"/>
+                <a:cs typeface="Segoe UI Semibold" pitchFamily="34" charset="-120"/>
+              </a:rPr>
+              <a:t>next customer workshop</a:t>
+            </a:r>
+            <a:endParaRPr lang="en-US" sz="4000" dirty="0"/>
+          </a:p>
+        </p:txBody>
+      </p:sp>
+      <p:sp>
+        <p:nvSpPr>
+          <p:cNvPr id="6" name="Text 4"/>
+          <p:cNvSpPr/>
+          <p:nvPr/>
+        </p:nvSpPr>
+        <p:spPr>
+          <a:xfrm>
+            <a:off x="640080" y="3383280"/>
+            <a:ext cx="7406640" cy="822960"/>
+          </a:xfrm>
+          <a:prstGeom prst="rect">
+            <a:avLst/>
+          </a:prstGeom>
+          <a:noFill/>
+          <a:ln/>
+        </p:spPr>
+        <p:txBody>
+          <a:bodyPr wrap="square" rtlCol="0" anchor="ctr"/>
+          <a:lstStyle/>
+          <a:p>
+            <a:pPr algn="l" indent="0" marL="0">
+              <a:lnSpc>
+                <a:spcPct val="110000"/>
+              </a:lnSpc>
+              <a:buNone/>
+            </a:pPr>
+            <a:r>
+              <a:rPr lang="en-US" sz="1600" dirty="0">
+                <a:solidFill>
+                  <a:srgbClr val="CFCDE0"/>
+                </a:solidFill>
+                <a:latin typeface="Segoe UI" pitchFamily="34" charset="0"/>
+                <a:ea typeface="Segoe UI" pitchFamily="34" charset="-122"/>
+                <a:cs typeface="Segoe UI" pitchFamily="34" charset="-120"/>
+              </a:rPr>
+              <a:t>Internal enablement or external customer event — co-brand it, share the link, and let attendees build real agents hands-on.</a:t>
+            </a:r>
+            <a:endParaRPr lang="en-US" sz="1600" dirty="0"/>
+          </a:p>
+        </p:txBody>
+      </p:sp>
+      <p:sp>
+        <p:nvSpPr>
+          <p:cNvPr id="7" name="Shape 5"/>
+          <p:cNvSpPr/>
+          <p:nvPr/>
+        </p:nvSpPr>
+        <p:spPr>
+          <a:xfrm>
+            <a:off x="640080" y="4434840"/>
+            <a:ext cx="3657600" cy="1051560"/>
+          </a:xfrm>
+          <a:prstGeom prst="roundRect">
+            <a:avLst>
+              <a:gd name="adj" fmla="val 10435"/>
+            </a:avLst>
+          </a:prstGeom>
+          <a:solidFill>
+            <a:srgbClr val="221C3F"/>
+          </a:solidFill>
+          <a:ln w="12700">
+            <a:solidFill>
+              <a:srgbClr val="3B3460"/>
+            </a:solidFill>
+            <a:prstDash val="solid"/>
+          </a:ln>
+        </p:spPr>
+      </p:sp>
+      <p:sp>
+        <p:nvSpPr>
+          <p:cNvPr id="8" name="Text 6"/>
+          <p:cNvSpPr/>
+          <p:nvPr/>
+        </p:nvSpPr>
+        <p:spPr>
+          <a:xfrm>
+            <a:off x="932688" y="4590288"/>
+            <a:ext cx="3200400" cy="384048"/>
+          </a:xfrm>
+          <a:prstGeom prst="rect">
+            <a:avLst/>
+          </a:prstGeom>
+          <a:noFill/>
+          <a:ln/>
+        </p:spPr>
+        <p:txBody>
+          <a:bodyPr wrap="square" lIns="0" tIns="0" rIns="0" bIns="0" rtlCol="0" anchor="ctr"/>
+          <a:lstStyle/>
+          <a:p>
+            <a:pPr indent="0" marL="0">
+              <a:buNone/>
+            </a:pPr>
+            <a:r>
+              <a:rPr lang="en-US" sz="1700" b="1" dirty="0">
+                <a:solidFill>
+                  <a:srgbClr val="ECECF5"/>
+                </a:solidFill>
+                <a:latin typeface="Segoe UI Semibold" pitchFamily="34" charset="0"/>
+                <a:ea typeface="Segoe UI Semibold" pitchFamily="34" charset="-122"/>
+                <a:cs typeface="Segoe UI Semibold" pitchFamily="34" charset="-120"/>
+              </a:rPr>
+              <a:t>Michael Jiang</a:t>
+            </a:r>
+            <a:endParaRPr lang="en-US" sz="1700" dirty="0"/>
+          </a:p>
+        </p:txBody>
+      </p:sp>
+      <p:sp>
+        <p:nvSpPr>
+          <p:cNvPr id="9" name="Text 7"/>
+          <p:cNvSpPr/>
+          <p:nvPr/>
+        </p:nvSpPr>
+        <p:spPr>
+          <a:xfrm>
+            <a:off x="932688" y="4992624"/>
+            <a:ext cx="3200400" cy="347472"/>
+          </a:xfrm>
+          <a:prstGeom prst="rect">
+            <a:avLst/>
+          </a:prstGeom>
+          <a:noFill/>
+          <a:ln/>
+        </p:spPr>
+        <p:txBody>
+          <a:bodyPr wrap="square" lIns="0" tIns="0" rIns="0" bIns="0" rtlCol="0" anchor="ctr"/>
+          <a:lstStyle/>
+          <a:p>
+            <a:pPr indent="0" marL="0">
+              <a:buNone/>
+            </a:pPr>
+            <a:r>
+              <a:rPr lang="en-US" sz="1350" dirty="0">
+                <a:solidFill>
+                  <a:srgbClr val="22D3EE"/>
+                </a:solidFill>
+                <a:latin typeface="Segoe UI" pitchFamily="34" charset="0"/>
+                <a:ea typeface="Segoe UI" pitchFamily="34" charset="-122"/>
+                <a:cs typeface="Segoe UI" pitchFamily="34" charset="-120"/>
+              </a:rPr>
+              <a:t>zhijian@microsoft.com</a:t>
+            </a:r>
+            <a:endParaRPr lang="en-US" sz="1350" dirty="0"/>
+          </a:p>
+        </p:txBody>
+      </p:sp>
+      <p:sp>
+        <p:nvSpPr>
+          <p:cNvPr id="10" name="Text 8"/>
+          <p:cNvSpPr/>
+          <p:nvPr/>
+        </p:nvSpPr>
+        <p:spPr>
+          <a:xfrm>
+            <a:off x="640080" y="5806440"/>
+            <a:ext cx="7315200" cy="365760"/>
+          </a:xfrm>
+          <a:prstGeom prst="rect">
+            <a:avLst/>
+          </a:prstGeom>
+          <a:noFill/>
+          <a:ln/>
+        </p:spPr>
+        <p:txBody>
+          <a:bodyPr wrap="square" rtlCol="0" anchor="ctr"/>
+          <a:lstStyle/>
+          <a:p>
+            <a:pPr algn="l" indent="0" marL="0">
+              <a:buNone/>
+            </a:pPr>
+            <a:r>
+              <a:rPr lang="en-US" sz="1250" dirty="0">
+                <a:solidFill>
+                  <a:srgbClr val="B4B1CC"/>
+                </a:solidFill>
+                <a:latin typeface="Segoe UI" pitchFamily="34" charset="0"/>
+                <a:ea typeface="Segoe UI" pitchFamily="34" charset="-122"/>
+                <a:cs typeface="Segoe UI" pitchFamily="34" charset="-120"/>
+              </a:rPr>
+              <a:t>Microsoft MCAPS Core — Agent Asia Team</a:t>
+            </a:r>
+            <a:endParaRPr lang="en-US" sz="1250" dirty="0"/>
+          </a:p>
+        </p:txBody>
+      </p:sp>
+      <p:pic>
+        <p:nvPicPr>
+          <p:cNvPr id="11" name="Image 0" descr="C:\D365DEMO\__Projects\Agent JumpStart 2\promo\img\michael.png">    </p:cNvPr>
+          <p:cNvPicPr>
+            <a:picLocks noChangeAspect="1"/>
+          </p:cNvPicPr>
+          <p:nvPr/>
+        </p:nvPicPr>
+        <p:blipFill>
+          <a:blip r:embed="rId1"/>
+          <a:stretch>
+            <a:fillRect/>
+          </a:stretch>
+        </p:blipFill>
+        <p:spPr>
+          <a:xfrm>
+            <a:off x="8549640" y="1783080"/>
+            <a:ext cx="2834640" cy="2834640"/>
+          </a:xfrm>
+          <a:prstGeom prst="rect">
+            <a:avLst/>
+          </a:prstGeom>
+        </p:spPr>
+      </p:pic>
+      <p:sp>
+        <p:nvSpPr>
+          <p:cNvPr id="12" name="Text 9"/>
+          <p:cNvSpPr/>
+          <p:nvPr/>
+        </p:nvSpPr>
+        <p:spPr>
+          <a:xfrm>
+            <a:off x="8275320" y="4709160"/>
+            <a:ext cx="3383280" cy="365760"/>
+          </a:xfrm>
+          <a:prstGeom prst="rect">
+            <a:avLst/>
+          </a:prstGeom>
+          <a:noFill/>
+          <a:ln/>
+        </p:spPr>
+        <p:txBody>
+          <a:bodyPr wrap="square" lIns="0" tIns="0" rIns="0" bIns="0" rtlCol="0" anchor="ctr"/>
+          <a:lstStyle/>
+          <a:p>
+            <a:pPr algn="ctr" indent="0" marL="0">
+              <a:buNone/>
+            </a:pPr>
+            <a:r>
+              <a:rPr lang="en-US" sz="1700" b="1" dirty="0">
+                <a:solidFill>
+                  <a:srgbClr val="ECECF5"/>
+                </a:solidFill>
+                <a:latin typeface="Segoe UI Semibold" pitchFamily="34" charset="0"/>
+                <a:ea typeface="Segoe UI Semibold" pitchFamily="34" charset="-122"/>
+                <a:cs typeface="Segoe UI Semibold" pitchFamily="34" charset="-120"/>
+              </a:rPr>
+              <a:t>Michael Jiang</a:t>
+            </a:r>
+            <a:endParaRPr lang="en-US" sz="1700" dirty="0"/>
+          </a:p>
+        </p:txBody>
+      </p:sp>
+      <p:sp>
+        <p:nvSpPr>
+          <p:cNvPr id="13" name="Text 10"/>
+          <p:cNvSpPr/>
+          <p:nvPr/>
+        </p:nvSpPr>
+        <p:spPr>
+          <a:xfrm>
+            <a:off x="8275320" y="5102352"/>
+            <a:ext cx="3383280" cy="548640"/>
+          </a:xfrm>
+          <a:prstGeom prst="rect">
+            <a:avLst/>
+          </a:prstGeom>
+          <a:noFill/>
+          <a:ln/>
+        </p:spPr>
+        <p:txBody>
+          <a:bodyPr wrap="square" lIns="0" tIns="0" rIns="0" bIns="0" rtlCol="0" anchor="ctr"/>
+          <a:lstStyle/>
+          <a:p>
+            <a:pPr algn="ctr" indent="0" marL="0">
+              <a:buNone/>
+            </a:pPr>
+            <a:r>
+              <a:rPr lang="en-US" sz="1200" dirty="0">
+                <a:solidFill>
+                  <a:srgbClr val="B4B1CC"/>
+                </a:solidFill>
+                <a:latin typeface="Segoe UI" pitchFamily="34" charset="0"/>
+                <a:ea typeface="Segoe UI" pitchFamily="34" charset="-122"/>
+                <a:cs typeface="Segoe UI" pitchFamily="34" charset="-120"/>
+              </a:rPr>
+              <a:t>Microsoft MCAPS Core — Agent Asia Team</a:t>
+            </a:r>
+            <a:endParaRPr lang="en-US" sz="1200" dirty="0"/>
+          </a:p>
+        </p:txBody>
+      </p:sp>
+    </p:spTree>
+  </p:cSld>
+  <p:clrMapOvr>
+    <a:masterClrMapping/>
+  </p:clrMapOvr>
+</p:sld>
+</file>
+
 <file path=ppt/slides/slide2.xml><?xml version="1.0" encoding="utf-8"?>
 <p:sld xmlns:a="http://schemas.openxmlformats.org/drawingml/2006/main" xmlns:r="http://schemas.openxmlformats.org/officeDocument/2006/relationships" xmlns:p="http://schemas.openxmlformats.org/presentationml/2006/main">
   <p:cSld name="Slide 2">
@@ -4310,6 +4878,62 @@
     <p:bg>
       <p:bgPr>
         <a:solidFill>
+          <a:srgbClr val="0F0D1A"/>
+        </a:solidFill>
+      </p:bgPr>
+    </p:bg>
+    <p:spTree>
+      <p:nvGrpSpPr>
+        <p:cNvPr id="1" name=""/>
+        <p:cNvGrpSpPr/>
+        <p:nvPr/>
+      </p:nvGrpSpPr>
+      <p:grpSpPr>
+        <a:xfrm>
+          <a:off x="0" y="0"/>
+          <a:ext cx="0" cy="0"/>
+          <a:chOff x="0" y="0"/>
+          <a:chExt cx="0" cy="0"/>
+        </a:xfrm>
+      </p:grpSpPr>
+      <p:pic>
+        <p:nvPicPr>
+          <p:cNvPr id="2" name="Image 0" descr="C:\D365DEMO\__Projects\Agent JumpStart 2\promo\img\agent-platform-blueprint-en.png">    </p:cNvPr>
+          <p:cNvPicPr>
+            <a:picLocks noChangeAspect="1"/>
+          </p:cNvPicPr>
+          <p:nvPr/>
+        </p:nvPicPr>
+        <p:blipFill>
+          <a:blip r:embed="rId1"/>
+          <a:stretch>
+            <a:fillRect/>
+          </a:stretch>
+        </p:blipFill>
+        <p:spPr>
+          <a:xfrm>
+            <a:off x="276149" y="155448"/>
+            <a:ext cx="11639398" cy="6547104"/>
+          </a:xfrm>
+          <a:prstGeom prst="rect">
+            <a:avLst/>
+          </a:prstGeom>
+        </p:spPr>
+      </p:pic>
+    </p:spTree>
+  </p:cSld>
+  <p:clrMapOvr>
+    <a:masterClrMapping/>
+  </p:clrMapOvr>
+</p:sld>
+</file>
+
+<file path=ppt/slides/slide5.xml><?xml version="1.0" encoding="utf-8"?>
+<p:sld xmlns:a="http://schemas.openxmlformats.org/drawingml/2006/main" xmlns:r="http://schemas.openxmlformats.org/officeDocument/2006/relationships" xmlns:p="http://schemas.openxmlformats.org/presentationml/2006/main">
+  <p:cSld name="Slide 5">
+    <p:bg>
+      <p:bgPr>
+        <a:solidFill>
           <a:srgbClr val="181334"/>
         </a:solidFill>
       </p:bgPr>
@@ -5139,9 +5763,9 @@
 </p:sld>
 </file>
 
-<file path=ppt/slides/slide5.xml><?xml version="1.0" encoding="utf-8"?>
+<file path=ppt/slides/slide6.xml><?xml version="1.0" encoding="utf-8"?>
 <p:sld xmlns:a="http://schemas.openxmlformats.org/drawingml/2006/main" xmlns:r="http://schemas.openxmlformats.org/officeDocument/2006/relationships" xmlns:p="http://schemas.openxmlformats.org/presentationml/2006/main">
-  <p:cSld name="Slide 5">
+  <p:cSld name="Slide 6">
     <p:bg>
       <p:bgPr>
         <a:solidFill>
@@ -6006,9 +6630,9 @@
 </p:sld>
 </file>
 
-<file path=ppt/slides/slide6.xml><?xml version="1.0" encoding="utf-8"?>
+<file path=ppt/slides/slide7.xml><?xml version="1.0" encoding="utf-8"?>
 <p:sld xmlns:a="http://schemas.openxmlformats.org/drawingml/2006/main" xmlns:r="http://schemas.openxmlformats.org/officeDocument/2006/relationships" xmlns:p="http://schemas.openxmlformats.org/presentationml/2006/main">
-  <p:cSld name="Slide 6">
+  <p:cSld name="Slide 7">
     <p:bg>
       <p:bgPr>
         <a:solidFill>
@@ -6760,9 +7384,9 @@
 </p:sld>
 </file>
 
-<file path=ppt/slides/slide7.xml><?xml version="1.0" encoding="utf-8"?>
+<file path=ppt/slides/slide8.xml><?xml version="1.0" encoding="utf-8"?>
 <p:sld xmlns:a="http://schemas.openxmlformats.org/drawingml/2006/main" xmlns:r="http://schemas.openxmlformats.org/officeDocument/2006/relationships" xmlns:p="http://schemas.openxmlformats.org/presentationml/2006/main">
-  <p:cSld name="Slide 7">
+  <p:cSld name="Slide 8">
     <p:bg>
       <p:bgPr>
         <a:solidFill>
@@ -7716,9 +8340,9 @@
 </p:sld>
 </file>
 
-<file path=ppt/slides/slide8.xml><?xml version="1.0" encoding="utf-8"?>
+<file path=ppt/slides/slide9.xml><?xml version="1.0" encoding="utf-8"?>
 <p:sld xmlns:a="http://schemas.openxmlformats.org/drawingml/2006/main" xmlns:r="http://schemas.openxmlformats.org/officeDocument/2006/relationships" xmlns:p="http://schemas.openxmlformats.org/presentationml/2006/main">
-  <p:cSld name="Slide 8">
+  <p:cSld name="Slide 9">
     <p:bg>
       <p:bgPr>
         <a:solidFill>
@@ -8441,485 +9065,6 @@
               <a:t>https://jzh24516.github.io/ai-agent-jumpstart-2/</a:t>
             </a:r>
             <a:endParaRPr lang="en-US" sz="2100" dirty="0"/>
-          </a:p>
-        </p:txBody>
-      </p:sp>
-    </p:spTree>
-  </p:cSld>
-  <p:clrMapOvr>
-    <a:masterClrMapping/>
-  </p:clrMapOvr>
-</p:sld>
-</file>
-
-<file path=ppt/slides/slide9.xml><?xml version="1.0" encoding="utf-8"?>
-<p:sld xmlns:a="http://schemas.openxmlformats.org/drawingml/2006/main" xmlns:r="http://schemas.openxmlformats.org/officeDocument/2006/relationships" xmlns:p="http://schemas.openxmlformats.org/presentationml/2006/main">
-  <p:cSld name="Slide 9">
-    <p:bg>
-      <p:bgPr>
-        <a:solidFill>
-          <a:srgbClr val="120F22"/>
-        </a:solidFill>
-      </p:bgPr>
-    </p:bg>
-    <p:spTree>
-      <p:nvGrpSpPr>
-        <p:cNvPr id="1" name=""/>
-        <p:cNvGrpSpPr/>
-        <p:nvPr/>
-      </p:nvGrpSpPr>
-      <p:grpSpPr>
-        <a:xfrm>
-          <a:off x="0" y="0"/>
-          <a:ext cx="0" cy="0"/>
-          <a:chOff x="0" y="0"/>
-          <a:chExt cx="0" cy="0"/>
-        </a:xfrm>
-      </p:grpSpPr>
-      <p:sp>
-        <p:nvSpPr>
-          <p:cNvPr id="2" name="Shape 0"/>
-          <p:cNvSpPr/>
-          <p:nvPr/>
-        </p:nvSpPr>
-        <p:spPr>
-          <a:xfrm>
-            <a:off x="-2194560" y="-2743200"/>
-            <a:ext cx="6858000" cy="6858000"/>
-          </a:xfrm>
-          <a:prstGeom prst="ellipse">
-            <a:avLst/>
-          </a:prstGeom>
-          <a:solidFill>
-            <a:srgbClr val="7C3AED">
-              <a:alpha val="22000"/>
-            </a:srgbClr>
-          </a:solidFill>
-          <a:ln/>
-        </p:spPr>
-      </p:sp>
-      <p:sp>
-        <p:nvSpPr>
-          <p:cNvPr id="3" name="Shape 1"/>
-          <p:cNvSpPr/>
-          <p:nvPr/>
-        </p:nvSpPr>
-        <p:spPr>
-          <a:xfrm>
-            <a:off x="8412480" y="4023360"/>
-            <a:ext cx="6400800" cy="6400800"/>
-          </a:xfrm>
-          <a:prstGeom prst="ellipse">
-            <a:avLst/>
-          </a:prstGeom>
-          <a:solidFill>
-            <a:srgbClr val="EC4899">
-              <a:alpha val="18000"/>
-            </a:srgbClr>
-          </a:solidFill>
-          <a:ln/>
-        </p:spPr>
-      </p:sp>
-      <p:sp>
-        <p:nvSpPr>
-          <p:cNvPr id="4" name="Text 2"/>
-          <p:cNvSpPr/>
-          <p:nvPr/>
-        </p:nvSpPr>
-        <p:spPr>
-          <a:xfrm>
-            <a:off x="640080" y="822960"/>
-            <a:ext cx="4572000" cy="365760"/>
-          </a:xfrm>
-          <a:prstGeom prst="rect">
-            <a:avLst/>
-          </a:prstGeom>
-          <a:noFill/>
-          <a:ln/>
-        </p:spPr>
-        <p:txBody>
-          <a:bodyPr wrap="square" rtlCol="0" anchor="ctr"/>
-          <a:lstStyle/>
-          <a:p>
-            <a:pPr algn="l" indent="0" marL="0">
-              <a:buNone/>
-            </a:pPr>
-            <a:r>
-              <a:rPr lang="en-US" sz="1200" b="1" dirty="0">
-                <a:solidFill>
-                  <a:srgbClr val="F472B6"/>
-                </a:solidFill>
-                <a:latin typeface="Segoe UI" pitchFamily="34" charset="0"/>
-                <a:ea typeface="Segoe UI" pitchFamily="34" charset="-122"/>
-                <a:cs typeface="Segoe UI" pitchFamily="34" charset="-120"/>
-              </a:rPr>
-              <a:t>● </a:t>
-            </a:r>
-            <a:pPr algn="l" indent="0" marL="0">
-              <a:buNone/>
-            </a:pPr>
-            <a:r>
-              <a:rPr lang="en-US" sz="1200" b="1" dirty="0">
-                <a:solidFill>
-                  <a:srgbClr val="E9E6FF"/>
-                </a:solidFill>
-                <a:latin typeface="Segoe UI" pitchFamily="34" charset="0"/>
-                <a:ea typeface="Segoe UI" pitchFamily="34" charset="-122"/>
-                <a:cs typeface="Segoe UI" pitchFamily="34" charset="-120"/>
-              </a:rPr>
-              <a:t>Ready when you are</a:t>
-            </a:r>
-            <a:endParaRPr lang="en-US" sz="1200" dirty="0"/>
-          </a:p>
-        </p:txBody>
-      </p:sp>
-      <p:sp>
-        <p:nvSpPr>
-          <p:cNvPr id="5" name="Text 3"/>
-          <p:cNvSpPr/>
-          <p:nvPr/>
-        </p:nvSpPr>
-        <p:spPr>
-          <a:xfrm>
-            <a:off x="603504" y="1554480"/>
-            <a:ext cx="7589520" cy="1737360"/>
-          </a:xfrm>
-          <a:prstGeom prst="rect">
-            <a:avLst/>
-          </a:prstGeom>
-          <a:noFill/>
-          <a:ln/>
-        </p:spPr>
-        <p:txBody>
-          <a:bodyPr wrap="square" lIns="0" tIns="0" rIns="0" bIns="0" rtlCol="0" anchor="ctr"/>
-          <a:lstStyle/>
-          <a:p>
-            <a:pPr algn="l" indent="0" marL="0">
-              <a:lnSpc>
-                <a:spcPct val="100000"/>
-              </a:lnSpc>
-              <a:buNone/>
-            </a:pPr>
-            <a:r>
-              <a:rPr lang="en-US" sz="4000" b="1" dirty="0">
-                <a:solidFill>
-                  <a:srgbClr val="FFFFFF"/>
-                </a:solidFill>
-                <a:latin typeface="Segoe UI Semibold" pitchFamily="34" charset="0"/>
-                <a:ea typeface="Segoe UI Semibold" pitchFamily="34" charset="-122"/>
-                <a:cs typeface="Segoe UI Semibold" pitchFamily="34" charset="-120"/>
-              </a:rPr>
-              <a:t>Bring JumpStart v2 to your</a:t>
-            </a:r>
-            <a:endParaRPr lang="en-US" sz="4000" dirty="0"/>
-          </a:p>
-          <a:p>
-            <a:pPr algn="l" indent="0" marL="0">
-              <a:lnSpc>
-                <a:spcPct val="100000"/>
-              </a:lnSpc>
-              <a:buNone/>
-            </a:pPr>
-            <a:r>
-              <a:rPr lang="en-US" sz="4000" b="1" dirty="0">
-                <a:solidFill>
-                  <a:srgbClr val="A78BFA"/>
-                </a:solidFill>
-                <a:latin typeface="Segoe UI Semibold" pitchFamily="34" charset="0"/>
-                <a:ea typeface="Segoe UI Semibold" pitchFamily="34" charset="-122"/>
-                <a:cs typeface="Segoe UI Semibold" pitchFamily="34" charset="-120"/>
-              </a:rPr>
-              <a:t>next customer workshop</a:t>
-            </a:r>
-            <a:endParaRPr lang="en-US" sz="4000" dirty="0"/>
-          </a:p>
-        </p:txBody>
-      </p:sp>
-      <p:sp>
-        <p:nvSpPr>
-          <p:cNvPr id="6" name="Text 4"/>
-          <p:cNvSpPr/>
-          <p:nvPr/>
-        </p:nvSpPr>
-        <p:spPr>
-          <a:xfrm>
-            <a:off x="640080" y="3383280"/>
-            <a:ext cx="7406640" cy="822960"/>
-          </a:xfrm>
-          <a:prstGeom prst="rect">
-            <a:avLst/>
-          </a:prstGeom>
-          <a:noFill/>
-          <a:ln/>
-        </p:spPr>
-        <p:txBody>
-          <a:bodyPr wrap="square" rtlCol="0" anchor="ctr"/>
-          <a:lstStyle/>
-          <a:p>
-            <a:pPr algn="l" indent="0" marL="0">
-              <a:lnSpc>
-                <a:spcPct val="110000"/>
-              </a:lnSpc>
-              <a:buNone/>
-            </a:pPr>
-            <a:r>
-              <a:rPr lang="en-US" sz="1600" dirty="0">
-                <a:solidFill>
-                  <a:srgbClr val="CFCDE0"/>
-                </a:solidFill>
-                <a:latin typeface="Segoe UI" pitchFamily="34" charset="0"/>
-                <a:ea typeface="Segoe UI" pitchFamily="34" charset="-122"/>
-                <a:cs typeface="Segoe UI" pitchFamily="34" charset="-120"/>
-              </a:rPr>
-              <a:t>Internal enablement or external customer event — co-brand it, share the link, and let attendees build real agents hands-on.</a:t>
-            </a:r>
-            <a:endParaRPr lang="en-US" sz="1600" dirty="0"/>
-          </a:p>
-        </p:txBody>
-      </p:sp>
-      <p:sp>
-        <p:nvSpPr>
-          <p:cNvPr id="7" name="Shape 5"/>
-          <p:cNvSpPr/>
-          <p:nvPr/>
-        </p:nvSpPr>
-        <p:spPr>
-          <a:xfrm>
-            <a:off x="640080" y="4434840"/>
-            <a:ext cx="3657600" cy="1051560"/>
-          </a:xfrm>
-          <a:prstGeom prst="roundRect">
-            <a:avLst>
-              <a:gd name="adj" fmla="val 10435"/>
-            </a:avLst>
-          </a:prstGeom>
-          <a:solidFill>
-            <a:srgbClr val="221C3F"/>
-          </a:solidFill>
-          <a:ln w="12700">
-            <a:solidFill>
-              <a:srgbClr val="3B3460"/>
-            </a:solidFill>
-            <a:prstDash val="solid"/>
-          </a:ln>
-        </p:spPr>
-      </p:sp>
-      <p:sp>
-        <p:nvSpPr>
-          <p:cNvPr id="8" name="Text 6"/>
-          <p:cNvSpPr/>
-          <p:nvPr/>
-        </p:nvSpPr>
-        <p:spPr>
-          <a:xfrm>
-            <a:off x="932688" y="4590288"/>
-            <a:ext cx="3200400" cy="384048"/>
-          </a:xfrm>
-          <a:prstGeom prst="rect">
-            <a:avLst/>
-          </a:prstGeom>
-          <a:noFill/>
-          <a:ln/>
-        </p:spPr>
-        <p:txBody>
-          <a:bodyPr wrap="square" lIns="0" tIns="0" rIns="0" bIns="0" rtlCol="0" anchor="ctr"/>
-          <a:lstStyle/>
-          <a:p>
-            <a:pPr indent="0" marL="0">
-              <a:buNone/>
-            </a:pPr>
-            <a:r>
-              <a:rPr lang="en-US" sz="1700" b="1" dirty="0">
-                <a:solidFill>
-                  <a:srgbClr val="ECECF5"/>
-                </a:solidFill>
-                <a:latin typeface="Segoe UI Semibold" pitchFamily="34" charset="0"/>
-                <a:ea typeface="Segoe UI Semibold" pitchFamily="34" charset="-122"/>
-                <a:cs typeface="Segoe UI Semibold" pitchFamily="34" charset="-120"/>
-              </a:rPr>
-              <a:t>Michael Jiang</a:t>
-            </a:r>
-            <a:endParaRPr lang="en-US" sz="1700" dirty="0"/>
-          </a:p>
-        </p:txBody>
-      </p:sp>
-      <p:sp>
-        <p:nvSpPr>
-          <p:cNvPr id="9" name="Text 7"/>
-          <p:cNvSpPr/>
-          <p:nvPr/>
-        </p:nvSpPr>
-        <p:spPr>
-          <a:xfrm>
-            <a:off x="932688" y="4992624"/>
-            <a:ext cx="3200400" cy="347472"/>
-          </a:xfrm>
-          <a:prstGeom prst="rect">
-            <a:avLst/>
-          </a:prstGeom>
-          <a:noFill/>
-          <a:ln/>
-        </p:spPr>
-        <p:txBody>
-          <a:bodyPr wrap="square" lIns="0" tIns="0" rIns="0" bIns="0" rtlCol="0" anchor="ctr"/>
-          <a:lstStyle/>
-          <a:p>
-            <a:pPr indent="0" marL="0">
-              <a:buNone/>
-            </a:pPr>
-            <a:r>
-              <a:rPr lang="en-US" sz="1350" dirty="0">
-                <a:solidFill>
-                  <a:srgbClr val="22D3EE"/>
-                </a:solidFill>
-                <a:latin typeface="Segoe UI" pitchFamily="34" charset="0"/>
-                <a:ea typeface="Segoe UI" pitchFamily="34" charset="-122"/>
-                <a:cs typeface="Segoe UI" pitchFamily="34" charset="-120"/>
-              </a:rPr>
-              <a:t>zhijian@microsoft.com</a:t>
-            </a:r>
-            <a:endParaRPr lang="en-US" sz="1350" dirty="0"/>
-          </a:p>
-        </p:txBody>
-      </p:sp>
-      <p:sp>
-        <p:nvSpPr>
-          <p:cNvPr id="10" name="Text 8"/>
-          <p:cNvSpPr/>
-          <p:nvPr/>
-        </p:nvSpPr>
-        <p:spPr>
-          <a:xfrm>
-            <a:off x="640080" y="5806440"/>
-            <a:ext cx="7315200" cy="365760"/>
-          </a:xfrm>
-          <a:prstGeom prst="rect">
-            <a:avLst/>
-          </a:prstGeom>
-          <a:noFill/>
-          <a:ln/>
-        </p:spPr>
-        <p:txBody>
-          <a:bodyPr wrap="square" rtlCol="0" anchor="ctr"/>
-          <a:lstStyle/>
-          <a:p>
-            <a:pPr algn="l" indent="0" marL="0">
-              <a:buNone/>
-            </a:pPr>
-            <a:r>
-              <a:rPr lang="en-US" sz="1250" dirty="0">
-                <a:solidFill>
-                  <a:srgbClr val="B4B1CC"/>
-                </a:solidFill>
-                <a:latin typeface="Segoe UI" pitchFamily="34" charset="0"/>
-                <a:ea typeface="Segoe UI" pitchFamily="34" charset="-122"/>
-                <a:cs typeface="Segoe UI" pitchFamily="34" charset="-120"/>
-              </a:rPr>
-              <a:t>Microsoft MCAPS Core — Agent Asia Team</a:t>
-            </a:r>
-            <a:endParaRPr lang="en-US" sz="1250" dirty="0"/>
-          </a:p>
-        </p:txBody>
-      </p:sp>
-      <p:pic>
-        <p:nvPicPr>
-          <p:cNvPr id="11" name="Image 0" descr="C:\D365DEMO\__Projects\Agent JumpStart 2\promo\img\michael.png">    </p:cNvPr>
-          <p:cNvPicPr>
-            <a:picLocks noChangeAspect="1"/>
-          </p:cNvPicPr>
-          <p:nvPr/>
-        </p:nvPicPr>
-        <p:blipFill>
-          <a:blip r:embed="rId1"/>
-          <a:stretch>
-            <a:fillRect/>
-          </a:stretch>
-        </p:blipFill>
-        <p:spPr>
-          <a:xfrm>
-            <a:off x="8549640" y="1783080"/>
-            <a:ext cx="2834640" cy="2834640"/>
-          </a:xfrm>
-          <a:prstGeom prst="rect">
-            <a:avLst/>
-          </a:prstGeom>
-        </p:spPr>
-      </p:pic>
-      <p:sp>
-        <p:nvSpPr>
-          <p:cNvPr id="12" name="Text 9"/>
-          <p:cNvSpPr/>
-          <p:nvPr/>
-        </p:nvSpPr>
-        <p:spPr>
-          <a:xfrm>
-            <a:off x="8275320" y="4709160"/>
-            <a:ext cx="3383280" cy="365760"/>
-          </a:xfrm>
-          <a:prstGeom prst="rect">
-            <a:avLst/>
-          </a:prstGeom>
-          <a:noFill/>
-          <a:ln/>
-        </p:spPr>
-        <p:txBody>
-          <a:bodyPr wrap="square" lIns="0" tIns="0" rIns="0" bIns="0" rtlCol="0" anchor="ctr"/>
-          <a:lstStyle/>
-          <a:p>
-            <a:pPr algn="ctr" indent="0" marL="0">
-              <a:buNone/>
-            </a:pPr>
-            <a:r>
-              <a:rPr lang="en-US" sz="1700" b="1" dirty="0">
-                <a:solidFill>
-                  <a:srgbClr val="ECECF5"/>
-                </a:solidFill>
-                <a:latin typeface="Segoe UI Semibold" pitchFamily="34" charset="0"/>
-                <a:ea typeface="Segoe UI Semibold" pitchFamily="34" charset="-122"/>
-                <a:cs typeface="Segoe UI Semibold" pitchFamily="34" charset="-120"/>
-              </a:rPr>
-              <a:t>Michael Jiang</a:t>
-            </a:r>
-            <a:endParaRPr lang="en-US" sz="1700" dirty="0"/>
-          </a:p>
-        </p:txBody>
-      </p:sp>
-      <p:sp>
-        <p:nvSpPr>
-          <p:cNvPr id="13" name="Text 10"/>
-          <p:cNvSpPr/>
-          <p:nvPr/>
-        </p:nvSpPr>
-        <p:spPr>
-          <a:xfrm>
-            <a:off x="8275320" y="5102352"/>
-            <a:ext cx="3383280" cy="548640"/>
-          </a:xfrm>
-          <a:prstGeom prst="rect">
-            <a:avLst/>
-          </a:prstGeom>
-          <a:noFill/>
-          <a:ln/>
-        </p:spPr>
-        <p:txBody>
-          <a:bodyPr wrap="square" lIns="0" tIns="0" rIns="0" bIns="0" rtlCol="0" anchor="ctr"/>
-          <a:lstStyle/>
-          <a:p>
-            <a:pPr algn="ctr" indent="0" marL="0">
-              <a:buNone/>
-            </a:pPr>
-            <a:r>
-              <a:rPr lang="en-US" sz="1200" dirty="0">
-                <a:solidFill>
-                  <a:srgbClr val="B4B1CC"/>
-                </a:solidFill>
-                <a:latin typeface="Segoe UI" pitchFamily="34" charset="0"/>
-                <a:ea typeface="Segoe UI" pitchFamily="34" charset="-122"/>
-                <a:cs typeface="Segoe UI" pitchFamily="34" charset="-120"/>
-              </a:rPr>
-              <a:t>Microsoft MCAPS Core — Agent Asia Team</a:t>
-            </a:r>
-            <a:endParaRPr lang="en-US" sz="1200" dirty="0"/>
           </a:p>
         </p:txBody>
       </p:sp>

</xml_diff>